<commit_message>
Finished Born rule video
</commit_message>
<xml_diff>
--- a/2026/20260701-BornIsEntropy.pptx
+++ b/2026/20260701-BornIsEntropy.pptx
@@ -223,7 +223,7 @@
           <a:p>
             <a:fld id="{E119C704-B8F9-449B-B828-36D786A1FE73}" type="datetimeFigureOut">
               <a:rPr lang="en-US" smtClean="0"/>
-              <a:t>6/28/2026</a:t>
+              <a:t>6/29/2026</a:t>
             </a:fld>
             <a:endParaRPr lang="en-US"/>
           </a:p>
@@ -621,6 +621,101 @@
           <a:bodyPr/>
           <a:lstStyle/>
           <a:p>
+            <a:r>
+              <a:rPr lang="en-US" dirty="0"/>
+              <a:t>So, why is this interesting? First, because having more way to understand the same things gives you more understanding… Second, at least for me, seeing the geometry makes me understand a lot more why things have to be in a certain way. But there is one more conceptual reason. Since the Born rule is a relationship between a preparation and a measurement, it is technically a relationship between two different spaces: the space of initial states and the space of final states. But some measurements are destructive, so you don’t really even have a well-defined space of final states. The inner product, instead, is technically defined on elements of a single space. So, conceptually, there is a little bit of a problem. There is no such problem for entropy: the entropy is the variability of the preparation. The mixture of the two states is defined at equal time, on the same space. It then also meshes well with a lot of other results in Reverse Physics, like that the </a:t>
+            </a:r>
+            <a:r>
+              <a:rPr lang="en-US" dirty="0" err="1"/>
+              <a:t>Schroedinger</a:t>
+            </a:r>
+            <a:r>
+              <a:rPr lang="en-US" dirty="0"/>
+              <a:t> equation is exactly the evolution that conserves entropy. So, all in all, once you get used to it, there are a lot of advantages… which you can learn if you follow our research on the Assumptions of Physics through this channel, our other research channel, our website and lots of material that we put there. Hope to see you next time!</a:t>
+            </a:r>
+          </a:p>
+        </p:txBody>
+      </p:sp>
+      <p:sp>
+        <p:nvSpPr>
+          <p:cNvPr id="4" name="Slide Number Placeholder 3"/>
+          <p:cNvSpPr>
+            <a:spLocks noGrp="1"/>
+          </p:cNvSpPr>
+          <p:nvPr>
+            <p:ph type="sldNum" sz="quarter" idx="5"/>
+          </p:nvPr>
+        </p:nvSpPr>
+        <p:spPr/>
+        <p:txBody>
+          <a:bodyPr/>
+          <a:lstStyle/>
+          <a:p>
+            <a:fld id="{A154F452-85BD-4268-B680-C313DBFDCEB3}" type="slidenum">
+              <a:rPr lang="en-US" smtClean="0"/>
+              <a:t>18</a:t>
+            </a:fld>
+            <a:endParaRPr lang="en-US"/>
+          </a:p>
+        </p:txBody>
+      </p:sp>
+    </p:spTree>
+    <p:extLst>
+      <p:ext uri="{BB962C8B-B14F-4D97-AF65-F5344CB8AC3E}">
+        <p14:creationId xmlns:p14="http://schemas.microsoft.com/office/powerpoint/2010/main" val="3373002429"/>
+      </p:ext>
+    </p:extLst>
+  </p:cSld>
+  <p:clrMapOvr>
+    <a:masterClrMapping/>
+  </p:clrMapOvr>
+</p:notes>
+</file>
+
+<file path=ppt/notesSlides/notesSlide3.xml><?xml version="1.0" encoding="utf-8"?>
+<p:notes xmlns:a="http://schemas.openxmlformats.org/drawingml/2006/main" xmlns:r="http://schemas.openxmlformats.org/officeDocument/2006/relationships" xmlns:p="http://schemas.openxmlformats.org/presentationml/2006/main">
+  <p:cSld>
+    <p:spTree>
+      <p:nvGrpSpPr>
+        <p:cNvPr id="1" name=""/>
+        <p:cNvGrpSpPr/>
+        <p:nvPr/>
+      </p:nvGrpSpPr>
+      <p:grpSpPr>
+        <a:xfrm>
+          <a:off x="0" y="0"/>
+          <a:ext cx="0" cy="0"/>
+          <a:chOff x="0" y="0"/>
+          <a:chExt cx="0" cy="0"/>
+        </a:xfrm>
+      </p:grpSpPr>
+      <p:sp>
+        <p:nvSpPr>
+          <p:cNvPr id="2" name="Slide Image Placeholder 1"/>
+          <p:cNvSpPr>
+            <a:spLocks noGrp="1" noRot="1" noChangeAspect="1"/>
+          </p:cNvSpPr>
+          <p:nvPr>
+            <p:ph type="sldImg"/>
+          </p:nvPr>
+        </p:nvSpPr>
+        <p:spPr/>
+      </p:sp>
+      <p:sp>
+        <p:nvSpPr>
+          <p:cNvPr id="3" name="Notes Placeholder 2"/>
+          <p:cNvSpPr>
+            <a:spLocks noGrp="1"/>
+          </p:cNvSpPr>
+          <p:nvPr>
+            <p:ph type="body" idx="1"/>
+          </p:nvPr>
+        </p:nvSpPr>
+        <p:spPr/>
+        <p:txBody>
+          <a:bodyPr/>
+          <a:lstStyle/>
+          <a:p>
             <a:endParaRPr lang="en-US" dirty="0"/>
           </a:p>
         </p:txBody>
@@ -808,7 +903,7 @@
           <a:p>
             <a:fld id="{DBFECF9E-8B09-4099-B1BA-6ADDA94A0342}" type="datetime1">
               <a:rPr lang="en-US" smtClean="0"/>
-              <a:t>6/28/2026</a:t>
+              <a:t>6/29/2026</a:t>
             </a:fld>
             <a:endParaRPr lang="en-US"/>
           </a:p>
@@ -1312,7 +1407,7 @@
           <a:p>
             <a:fld id="{C2E4689B-730B-4AF6-A7AC-5BF745BF6CF6}" type="datetime1">
               <a:rPr lang="en-US" smtClean="0"/>
-              <a:t>6/28/2026</a:t>
+              <a:t>6/29/2026</a:t>
             </a:fld>
             <a:endParaRPr lang="en-US"/>
           </a:p>
@@ -1523,7 +1618,7 @@
           <a:p>
             <a:fld id="{849CD730-13C7-4BA8-9C49-4344F22DB36C}" type="datetime1">
               <a:rPr lang="en-US" smtClean="0"/>
-              <a:t>6/28/2026</a:t>
+              <a:t>6/29/2026</a:t>
             </a:fld>
             <a:endParaRPr lang="en-US"/>
           </a:p>
@@ -1752,7 +1847,7 @@
           <a:p>
             <a:fld id="{14040F82-CAAF-492E-A3B6-9D23E7AB0A58}" type="datetime1">
               <a:rPr lang="en-US" smtClean="0"/>
-              <a:t>6/28/2026</a:t>
+              <a:t>6/29/2026</a:t>
             </a:fld>
             <a:endParaRPr lang="en-US" dirty="0"/>
           </a:p>
@@ -2002,7 +2097,7 @@
           <a:p>
             <a:fld id="{5E94585C-5462-4635-A827-CBBCD3A2E6B8}" type="datetime1">
               <a:rPr lang="en-US" smtClean="0"/>
-              <a:t>6/28/2026</a:t>
+              <a:t>6/29/2026</a:t>
             </a:fld>
             <a:endParaRPr lang="en-US"/>
           </a:p>
@@ -2270,7 +2365,7 @@
           <a:p>
             <a:fld id="{B09B1218-991B-4184-B0F8-198D0FAC17F9}" type="datetime1">
               <a:rPr lang="en-US" smtClean="0"/>
-              <a:t>6/28/2026</a:t>
+              <a:t>6/29/2026</a:t>
             </a:fld>
             <a:endParaRPr lang="en-US"/>
           </a:p>
@@ -2685,7 +2780,7 @@
           <a:p>
             <a:fld id="{9555B3F8-63BD-45A8-8D64-7C6391B4DEC4}" type="datetime1">
               <a:rPr lang="en-US" smtClean="0"/>
-              <a:t>6/28/2026</a:t>
+              <a:t>6/29/2026</a:t>
             </a:fld>
             <a:endParaRPr lang="en-US"/>
           </a:p>
@@ -2829,7 +2924,7 @@
           <a:p>
             <a:fld id="{B6287A86-4DED-4531-AD0C-FE6F48B43375}" type="datetime1">
               <a:rPr lang="en-US" smtClean="0"/>
-              <a:t>6/28/2026</a:t>
+              <a:t>6/29/2026</a:t>
             </a:fld>
             <a:endParaRPr lang="en-US"/>
           </a:p>
@@ -2945,7 +3040,7 @@
           <a:p>
             <a:fld id="{2BB7EE58-DC87-4D11-AA22-E3A6718A2E80}" type="datetime1">
               <a:rPr lang="en-US" smtClean="0"/>
-              <a:t>6/28/2026</a:t>
+              <a:t>6/29/2026</a:t>
             </a:fld>
             <a:endParaRPr lang="en-US" dirty="0"/>
           </a:p>
@@ -3260,7 +3355,7 @@
           <a:p>
             <a:fld id="{F681BEE4-EED9-4644-8E5D-BAF3D04BB52D}" type="datetime1">
               <a:rPr lang="en-US" smtClean="0"/>
-              <a:t>6/28/2026</a:t>
+              <a:t>6/29/2026</a:t>
             </a:fld>
             <a:endParaRPr lang="en-US"/>
           </a:p>
@@ -3551,7 +3646,7 @@
           <a:p>
             <a:fld id="{6E9AAFE7-E238-4DAA-A26B-A60C405FBFD6}" type="datetime1">
               <a:rPr lang="en-US" smtClean="0"/>
-              <a:t>6/28/2026</a:t>
+              <a:t>6/29/2026</a:t>
             </a:fld>
             <a:endParaRPr lang="en-US"/>
           </a:p>
@@ -3795,7 +3890,7 @@
           <a:p>
             <a:fld id="{F865660A-2FFB-4EA8-A917-E41016B95ABA}" type="datetime1">
               <a:rPr lang="en-US" smtClean="0"/>
-              <a:t>6/28/2026</a:t>
+              <a:t>6/29/2026</a:t>
             </a:fld>
             <a:endParaRPr lang="en-US" dirty="0"/>
           </a:p>
@@ -5540,8 +5635,8 @@
           </a:p>
         </p:txBody>
       </p:sp>
-      <mc:AlternateContent xmlns:mc="http://schemas.openxmlformats.org/markup-compatibility/2006">
-        <mc:Choice xmlns:a14="http://schemas.microsoft.com/office/drawing/2010/main" Requires="a14">
+      <mc:AlternateContent xmlns:mc="http://schemas.openxmlformats.org/markup-compatibility/2006" xmlns:a14="http://schemas.microsoft.com/office/drawing/2010/main">
+        <mc:Choice Requires="a14">
           <p:sp>
             <p:nvSpPr>
               <p:cNvPr id="10" name="TextBox 9">
@@ -5727,7 +5822,7 @@
             </p:txBody>
           </p:sp>
         </mc:Choice>
-        <mc:Fallback>
+        <mc:Fallback xmlns="">
           <p:sp>
             <p:nvSpPr>
               <p:cNvPr id="10" name="TextBox 9">
@@ -5772,8 +5867,8 @@
           </p:sp>
         </mc:Fallback>
       </mc:AlternateContent>
-      <mc:AlternateContent xmlns:mc="http://schemas.openxmlformats.org/markup-compatibility/2006">
-        <mc:Choice xmlns:a14="http://schemas.microsoft.com/office/drawing/2010/main" Requires="a14">
+      <mc:AlternateContent xmlns:mc="http://schemas.openxmlformats.org/markup-compatibility/2006" xmlns:a14="http://schemas.microsoft.com/office/drawing/2010/main">
+        <mc:Choice Requires="a14">
           <p:sp>
             <p:nvSpPr>
               <p:cNvPr id="17" name="TextBox 16">
@@ -5888,7 +5983,7 @@
             </p:txBody>
           </p:sp>
         </mc:Choice>
-        <mc:Fallback>
+        <mc:Fallback xmlns="">
           <p:sp>
             <p:nvSpPr>
               <p:cNvPr id="17" name="TextBox 16">
@@ -5933,8 +6028,8 @@
           </p:sp>
         </mc:Fallback>
       </mc:AlternateContent>
-      <mc:AlternateContent xmlns:mc="http://schemas.openxmlformats.org/markup-compatibility/2006">
-        <mc:Choice xmlns:a14="http://schemas.microsoft.com/office/drawing/2010/main" Requires="a14">
+      <mc:AlternateContent xmlns:mc="http://schemas.openxmlformats.org/markup-compatibility/2006" xmlns:a14="http://schemas.microsoft.com/office/drawing/2010/main">
+        <mc:Choice Requires="a14">
           <p:sp>
             <p:nvSpPr>
               <p:cNvPr id="18" name="TextBox 17">
@@ -6070,7 +6165,7 @@
             </p:txBody>
           </p:sp>
         </mc:Choice>
-        <mc:Fallback>
+        <mc:Fallback xmlns="">
           <p:sp>
             <p:nvSpPr>
               <p:cNvPr id="18" name="TextBox 17">
@@ -6151,8 +6246,8 @@
           <a:chExt cx="0" cy="0"/>
         </a:xfrm>
       </p:grpSpPr>
-      <mc:AlternateContent xmlns:mc="http://schemas.openxmlformats.org/markup-compatibility/2006">
-        <mc:Choice xmlns:a14="http://schemas.microsoft.com/office/drawing/2010/main" Requires="a14">
+      <mc:AlternateContent xmlns:mc="http://schemas.openxmlformats.org/markup-compatibility/2006" xmlns:a14="http://schemas.microsoft.com/office/drawing/2010/main">
+        <mc:Choice Requires="a14">
           <p:sp>
             <p:nvSpPr>
               <p:cNvPr id="17" name="TextBox 16">
@@ -6420,7 +6515,7 @@
             </p:txBody>
           </p:sp>
         </mc:Choice>
-        <mc:Fallback>
+        <mc:Fallback xmlns="">
           <p:sp>
             <p:nvSpPr>
               <p:cNvPr id="17" name="TextBox 16">
@@ -6633,8 +6728,8 @@
           </a:fontRef>
         </p:style>
       </p:cxnSp>
-      <mc:AlternateContent xmlns:mc="http://schemas.openxmlformats.org/markup-compatibility/2006">
-        <mc:Choice xmlns:a14="http://schemas.microsoft.com/office/drawing/2010/main" Requires="a14">
+      <mc:AlternateContent xmlns:mc="http://schemas.openxmlformats.org/markup-compatibility/2006" xmlns:a14="http://schemas.microsoft.com/office/drawing/2010/main">
+        <mc:Choice Requires="a14">
           <p:sp>
             <p:nvSpPr>
               <p:cNvPr id="22" name="TextBox 21">
@@ -6684,7 +6779,7 @@
             </p:txBody>
           </p:sp>
         </mc:Choice>
-        <mc:Fallback>
+        <mc:Fallback xmlns="">
           <p:sp>
             <p:nvSpPr>
               <p:cNvPr id="22" name="TextBox 21">
@@ -6729,8 +6824,8 @@
           </p:sp>
         </mc:Fallback>
       </mc:AlternateContent>
-      <mc:AlternateContent xmlns:mc="http://schemas.openxmlformats.org/markup-compatibility/2006">
-        <mc:Choice xmlns:a14="http://schemas.microsoft.com/office/drawing/2010/main" Requires="a14">
+      <mc:AlternateContent xmlns:mc="http://schemas.openxmlformats.org/markup-compatibility/2006" xmlns:a14="http://schemas.microsoft.com/office/drawing/2010/main">
+        <mc:Choice Requires="a14">
           <p:sp>
             <p:nvSpPr>
               <p:cNvPr id="23" name="TextBox 22">
@@ -6780,7 +6875,7 @@
             </p:txBody>
           </p:sp>
         </mc:Choice>
-        <mc:Fallback>
+        <mc:Fallback xmlns="">
           <p:sp>
             <p:nvSpPr>
               <p:cNvPr id="23" name="TextBox 22">
@@ -6825,8 +6920,8 @@
           </p:sp>
         </mc:Fallback>
       </mc:AlternateContent>
-      <mc:AlternateContent xmlns:mc="http://schemas.openxmlformats.org/markup-compatibility/2006">
-        <mc:Choice xmlns:a14="http://schemas.microsoft.com/office/drawing/2010/main" Requires="a14">
+      <mc:AlternateContent xmlns:mc="http://schemas.openxmlformats.org/markup-compatibility/2006" xmlns:a14="http://schemas.microsoft.com/office/drawing/2010/main">
+        <mc:Choice Requires="a14">
           <p:sp>
             <p:nvSpPr>
               <p:cNvPr id="24" name="TextBox 23">
@@ -6876,7 +6971,7 @@
             </p:txBody>
           </p:sp>
         </mc:Choice>
-        <mc:Fallback>
+        <mc:Fallback xmlns="">
           <p:sp>
             <p:nvSpPr>
               <p:cNvPr id="24" name="TextBox 23">
@@ -7011,8 +7106,8 @@
           </a:p>
         </p:txBody>
       </p:sp>
-      <mc:AlternateContent xmlns:mc="http://schemas.openxmlformats.org/markup-compatibility/2006">
-        <mc:Choice xmlns:a14="http://schemas.microsoft.com/office/drawing/2010/main" Requires="a14">
+      <mc:AlternateContent xmlns:mc="http://schemas.openxmlformats.org/markup-compatibility/2006" xmlns:a14="http://schemas.microsoft.com/office/drawing/2010/main">
+        <mc:Choice Requires="a14">
           <p:sp>
             <p:nvSpPr>
               <p:cNvPr id="29" name="TextBox 28">
@@ -7081,7 +7176,7 @@
             </p:txBody>
           </p:sp>
         </mc:Choice>
-        <mc:Fallback>
+        <mc:Fallback xmlns="">
           <p:sp>
             <p:nvSpPr>
               <p:cNvPr id="29" name="TextBox 28">
@@ -7126,8 +7221,8 @@
           </p:sp>
         </mc:Fallback>
       </mc:AlternateContent>
-      <mc:AlternateContent xmlns:mc="http://schemas.openxmlformats.org/markup-compatibility/2006">
-        <mc:Choice xmlns:a14="http://schemas.microsoft.com/office/drawing/2010/main" Requires="a14">
+      <mc:AlternateContent xmlns:mc="http://schemas.openxmlformats.org/markup-compatibility/2006" xmlns:a14="http://schemas.microsoft.com/office/drawing/2010/main">
+        <mc:Choice Requires="a14">
           <p:sp>
             <p:nvSpPr>
               <p:cNvPr id="30" name="TextBox 29">
@@ -7177,7 +7272,7 @@
             </p:txBody>
           </p:sp>
         </mc:Choice>
-        <mc:Fallback>
+        <mc:Fallback xmlns="">
           <p:sp>
             <p:nvSpPr>
               <p:cNvPr id="30" name="TextBox 29">
@@ -7222,8 +7317,8 @@
           </p:sp>
         </mc:Fallback>
       </mc:AlternateContent>
-      <mc:AlternateContent xmlns:mc="http://schemas.openxmlformats.org/markup-compatibility/2006">
-        <mc:Choice xmlns:a14="http://schemas.microsoft.com/office/drawing/2010/main" Requires="a14">
+      <mc:AlternateContent xmlns:mc="http://schemas.openxmlformats.org/markup-compatibility/2006" xmlns:a14="http://schemas.microsoft.com/office/drawing/2010/main">
+        <mc:Choice Requires="a14">
           <p:sp>
             <p:nvSpPr>
               <p:cNvPr id="32" name="TextBox 31">
@@ -7292,7 +7387,7 @@
             </p:txBody>
           </p:sp>
         </mc:Choice>
-        <mc:Fallback>
+        <mc:Fallback xmlns="">
           <p:sp>
             <p:nvSpPr>
               <p:cNvPr id="32" name="TextBox 31">
@@ -7337,8 +7432,8 @@
           </p:sp>
         </mc:Fallback>
       </mc:AlternateContent>
-      <mc:AlternateContent xmlns:mc="http://schemas.openxmlformats.org/markup-compatibility/2006">
-        <mc:Choice xmlns:a14="http://schemas.microsoft.com/office/drawing/2010/main" Requires="a14">
+      <mc:AlternateContent xmlns:mc="http://schemas.openxmlformats.org/markup-compatibility/2006" xmlns:a14="http://schemas.microsoft.com/office/drawing/2010/main">
+        <mc:Choice Requires="a14">
           <p:sp>
             <p:nvSpPr>
               <p:cNvPr id="4" name="TextBox 3">
@@ -7437,7 +7532,7 @@
             </p:txBody>
           </p:sp>
         </mc:Choice>
-        <mc:Fallback>
+        <mc:Fallback xmlns="">
           <p:sp>
             <p:nvSpPr>
               <p:cNvPr id="4" name="TextBox 3">
@@ -7482,8 +7577,8 @@
           </p:sp>
         </mc:Fallback>
       </mc:AlternateContent>
-      <mc:AlternateContent xmlns:mc="http://schemas.openxmlformats.org/markup-compatibility/2006">
-        <mc:Choice xmlns:a14="http://schemas.microsoft.com/office/drawing/2010/main" Requires="a14">
+      <mc:AlternateContent xmlns:mc="http://schemas.openxmlformats.org/markup-compatibility/2006" xmlns:a14="http://schemas.microsoft.com/office/drawing/2010/main">
+        <mc:Choice Requires="a14">
           <p:sp>
             <p:nvSpPr>
               <p:cNvPr id="6" name="TextBox 5">
@@ -7512,7 +7607,6 @@
               </a:bodyPr>
               <a:lstStyle/>
               <a:p>
-                <a:pPr/>
                 <a14:m>
                   <m:oMath xmlns:m="http://schemas.openxmlformats.org/officeDocument/2006/math">
                     <m:r>
@@ -7694,13 +7788,7 @@
                           <a:rPr lang="en-US" sz="3200" i="1">
                             <a:latin typeface="Cambria Math" panose="02040503050406030204" pitchFamily="18" charset="0"/>
                           </a:rPr>
-                          <m:t>1</m:t>
-                        </m:r>
-                        <m:r>
-                          <a:rPr lang="en-US" sz="3200" i="1">
-                            <a:latin typeface="Cambria Math" panose="02040503050406030204" pitchFamily="18" charset="0"/>
-                          </a:rPr>
-                          <m:t>−</m:t>
+                          <m:t>1−</m:t>
                         </m:r>
                         <m:rad>
                           <m:radPr>
@@ -7807,7 +7895,7 @@
             </p:txBody>
           </p:sp>
         </mc:Choice>
-        <mc:Fallback>
+        <mc:Fallback xmlns="">
           <p:sp>
             <p:nvSpPr>
               <p:cNvPr id="6" name="TextBox 5">
@@ -7902,8 +7990,8 @@
             </a:prstGeom>
           </p:spPr>
         </p:pic>
-        <mc:AlternateContent xmlns:mc="http://schemas.openxmlformats.org/markup-compatibility/2006">
-          <mc:Choice xmlns:a14="http://schemas.microsoft.com/office/drawing/2010/main" Requires="a14">
+        <mc:AlternateContent xmlns:mc="http://schemas.openxmlformats.org/markup-compatibility/2006" xmlns:a14="http://schemas.microsoft.com/office/drawing/2010/main">
+          <mc:Choice Requires="a14">
             <p:sp>
               <p:nvSpPr>
                 <p:cNvPr id="12" name="TextBox 11">
@@ -7970,7 +8058,7 @@
               </p:txBody>
             </p:sp>
           </mc:Choice>
-          <mc:Fallback>
+          <mc:Fallback xmlns="">
             <p:sp>
               <p:nvSpPr>
                 <p:cNvPr id="12" name="TextBox 11">
@@ -8015,8 +8103,8 @@
             </p:sp>
           </mc:Fallback>
         </mc:AlternateContent>
-        <mc:AlternateContent xmlns:mc="http://schemas.openxmlformats.org/markup-compatibility/2006">
-          <mc:Choice xmlns:a14="http://schemas.microsoft.com/office/drawing/2010/main" Requires="a14">
+        <mc:AlternateContent xmlns:mc="http://schemas.openxmlformats.org/markup-compatibility/2006" xmlns:a14="http://schemas.microsoft.com/office/drawing/2010/main">
+          <mc:Choice Requires="a14">
             <p:sp>
               <p:nvSpPr>
                 <p:cNvPr id="14" name="TextBox 13">
@@ -8104,7 +8192,7 @@
               </p:txBody>
             </p:sp>
           </mc:Choice>
-          <mc:Fallback>
+          <mc:Fallback xmlns="">
             <p:sp>
               <p:nvSpPr>
                 <p:cNvPr id="14" name="TextBox 13">
@@ -8160,87 +8248,6 @@
   <p:clrMapOvr>
     <a:masterClrMapping/>
   </p:clrMapOvr>
-  <p:timing>
-    <p:tnLst>
-      <p:par>
-        <p:cTn id="1" dur="indefinite" restart="never" nodeType="tmRoot">
-          <p:childTnLst>
-            <p:seq concurrent="1" nextAc="seek">
-              <p:cTn id="2" dur="indefinite" nodeType="mainSeq">
-                <p:childTnLst>
-                  <p:par>
-                    <p:cTn id="3" fill="hold">
-                      <p:stCondLst>
-                        <p:cond delay="indefinite"/>
-                        <p:cond evt="onBegin" delay="0">
-                          <p:tn val="2"/>
-                        </p:cond>
-                      </p:stCondLst>
-                      <p:childTnLst>
-                        <p:par>
-                          <p:cTn id="4" fill="hold">
-                            <p:stCondLst>
-                              <p:cond delay="0"/>
-                            </p:stCondLst>
-                            <p:childTnLst>
-                              <p:par>
-                                <p:cTn id="5" presetID="1" presetClass="entr" presetSubtype="0" fill="hold" grpId="0" nodeType="withEffect">
-                                  <p:stCondLst>
-                                    <p:cond delay="0"/>
-                                  </p:stCondLst>
-                                  <p:childTnLst>
-                                    <p:set>
-                                      <p:cBhvr>
-                                        <p:cTn id="6" dur="1" fill="hold">
-                                          <p:stCondLst>
-                                            <p:cond delay="0"/>
-                                          </p:stCondLst>
-                                        </p:cTn>
-                                        <p:tgtEl>
-                                          <p:spTgt spid="6"/>
-                                        </p:tgtEl>
-                                        <p:attrNameLst>
-                                          <p:attrName>style.visibility</p:attrName>
-                                        </p:attrNameLst>
-                                      </p:cBhvr>
-                                      <p:to>
-                                        <p:strVal val="visible"/>
-                                      </p:to>
-                                    </p:set>
-                                  </p:childTnLst>
-                                </p:cTn>
-                              </p:par>
-                            </p:childTnLst>
-                          </p:cTn>
-                        </p:par>
-                      </p:childTnLst>
-                    </p:cTn>
-                  </p:par>
-                </p:childTnLst>
-              </p:cTn>
-              <p:prevCondLst>
-                <p:cond evt="onPrev" delay="0">
-                  <p:tgtEl>
-                    <p:sldTgt/>
-                  </p:tgtEl>
-                </p:cond>
-              </p:prevCondLst>
-              <p:nextCondLst>
-                <p:cond evt="onNext" delay="0">
-                  <p:tgtEl>
-                    <p:sldTgt/>
-                  </p:tgtEl>
-                </p:cond>
-              </p:nextCondLst>
-            </p:seq>
-          </p:childTnLst>
-        </p:cTn>
-      </p:par>
-    </p:tnLst>
-    <p:bldLst>
-      <p:bldP spid="6" grpId="0"/>
-    </p:bldLst>
-  </p:timing>
 </p:sld>
 </file>
 
@@ -8308,8 +8315,8 @@
           </a:p>
         </p:txBody>
       </p:sp>
-      <mc:AlternateContent xmlns:mc="http://schemas.openxmlformats.org/markup-compatibility/2006">
-        <mc:Choice xmlns:a14="http://schemas.microsoft.com/office/drawing/2010/main" Requires="a14">
+      <mc:AlternateContent xmlns:mc="http://schemas.openxmlformats.org/markup-compatibility/2006" xmlns:a14="http://schemas.microsoft.com/office/drawing/2010/main">
+        <mc:Choice Requires="a14">
           <p:sp>
             <p:nvSpPr>
               <p:cNvPr id="5" name="TextBox 4">
@@ -8409,7 +8416,7 @@
             </p:txBody>
           </p:sp>
         </mc:Choice>
-        <mc:Fallback>
+        <mc:Fallback xmlns="">
           <p:sp>
             <p:nvSpPr>
               <p:cNvPr id="5" name="TextBox 4">
@@ -8701,8 +8708,8 @@
           </a:fontRef>
         </p:style>
       </p:cxnSp>
-      <mc:AlternateContent xmlns:mc="http://schemas.openxmlformats.org/markup-compatibility/2006">
-        <mc:Choice xmlns:a14="http://schemas.microsoft.com/office/drawing/2010/main" Requires="a14">
+      <mc:AlternateContent xmlns:mc="http://schemas.openxmlformats.org/markup-compatibility/2006" xmlns:a14="http://schemas.microsoft.com/office/drawing/2010/main">
+        <mc:Choice Requires="a14">
           <p:sp>
             <p:nvSpPr>
               <p:cNvPr id="12" name="TextBox 11">
@@ -8752,7 +8759,7 @@
             </p:txBody>
           </p:sp>
         </mc:Choice>
-        <mc:Fallback>
+        <mc:Fallback xmlns="">
           <p:sp>
             <p:nvSpPr>
               <p:cNvPr id="12" name="TextBox 11">
@@ -8797,8 +8804,8 @@
           </p:sp>
         </mc:Fallback>
       </mc:AlternateContent>
-      <mc:AlternateContent xmlns:mc="http://schemas.openxmlformats.org/markup-compatibility/2006">
-        <mc:Choice xmlns:a14="http://schemas.microsoft.com/office/drawing/2010/main" Requires="a14">
+      <mc:AlternateContent xmlns:mc="http://schemas.openxmlformats.org/markup-compatibility/2006" xmlns:a14="http://schemas.microsoft.com/office/drawing/2010/main">
+        <mc:Choice Requires="a14">
           <p:sp>
             <p:nvSpPr>
               <p:cNvPr id="14" name="TextBox 13">
@@ -8848,7 +8855,7 @@
             </p:txBody>
           </p:sp>
         </mc:Choice>
-        <mc:Fallback>
+        <mc:Fallback xmlns="">
           <p:sp>
             <p:nvSpPr>
               <p:cNvPr id="14" name="TextBox 13">
@@ -8893,8 +8900,8 @@
           </p:sp>
         </mc:Fallback>
       </mc:AlternateContent>
-      <mc:AlternateContent xmlns:mc="http://schemas.openxmlformats.org/markup-compatibility/2006">
-        <mc:Choice xmlns:a14="http://schemas.microsoft.com/office/drawing/2010/main" Requires="a14">
+      <mc:AlternateContent xmlns:mc="http://schemas.openxmlformats.org/markup-compatibility/2006" xmlns:a14="http://schemas.microsoft.com/office/drawing/2010/main">
+        <mc:Choice Requires="a14">
           <p:sp>
             <p:nvSpPr>
               <p:cNvPr id="16" name="TextBox 15">
@@ -8944,7 +8951,7 @@
             </p:txBody>
           </p:sp>
         </mc:Choice>
-        <mc:Fallback>
+        <mc:Fallback xmlns="">
           <p:sp>
             <p:nvSpPr>
               <p:cNvPr id="16" name="TextBox 15">
@@ -9213,8 +9220,8 @@
           </a:fontRef>
         </p:style>
       </p:cxnSp>
-      <mc:AlternateContent xmlns:mc="http://schemas.openxmlformats.org/markup-compatibility/2006">
-        <mc:Choice xmlns:a14="http://schemas.microsoft.com/office/drawing/2010/main" Requires="a14">
+      <mc:AlternateContent xmlns:mc="http://schemas.openxmlformats.org/markup-compatibility/2006" xmlns:a14="http://schemas.microsoft.com/office/drawing/2010/main">
+        <mc:Choice Requires="a14">
           <p:sp>
             <p:nvSpPr>
               <p:cNvPr id="57" name="TextBox 56">
@@ -9283,7 +9290,7 @@
             </p:txBody>
           </p:sp>
         </mc:Choice>
-        <mc:Fallback>
+        <mc:Fallback xmlns="">
           <p:sp>
             <p:nvSpPr>
               <p:cNvPr id="57" name="TextBox 56">
@@ -9563,8 +9570,8 @@
           </p:sp>
         </mc:Fallback>
       </mc:AlternateContent>
-      <mc:AlternateContent xmlns:mc="http://schemas.openxmlformats.org/markup-compatibility/2006">
-        <mc:Choice xmlns:a14="http://schemas.microsoft.com/office/drawing/2010/main" Requires="a14">
+      <mc:AlternateContent xmlns:mc="http://schemas.openxmlformats.org/markup-compatibility/2006" xmlns:a14="http://schemas.microsoft.com/office/drawing/2010/main">
+        <mc:Choice Requires="a14">
           <p:sp>
             <p:nvSpPr>
               <p:cNvPr id="18" name="TextBox 17">
@@ -9639,7 +9646,7 @@
             </p:txBody>
           </p:sp>
         </mc:Choice>
-        <mc:Fallback>
+        <mc:Fallback xmlns="">
           <p:sp>
             <p:nvSpPr>
               <p:cNvPr id="18" name="TextBox 17">
@@ -10093,8 +10100,8 @@
           </a:fontRef>
         </p:style>
       </p:cxnSp>
-      <mc:AlternateContent xmlns:mc="http://schemas.openxmlformats.org/markup-compatibility/2006">
-        <mc:Choice xmlns:a14="http://schemas.microsoft.com/office/drawing/2010/main" Requires="a14">
+      <mc:AlternateContent xmlns:mc="http://schemas.openxmlformats.org/markup-compatibility/2006" xmlns:a14="http://schemas.microsoft.com/office/drawing/2010/main">
+        <mc:Choice Requires="a14">
           <p:sp>
             <p:nvSpPr>
               <p:cNvPr id="12" name="TextBox 11">
@@ -10144,7 +10151,7 @@
             </p:txBody>
           </p:sp>
         </mc:Choice>
-        <mc:Fallback>
+        <mc:Fallback xmlns="">
           <p:sp>
             <p:nvSpPr>
               <p:cNvPr id="12" name="TextBox 11">
@@ -10189,8 +10196,8 @@
           </p:sp>
         </mc:Fallback>
       </mc:AlternateContent>
-      <mc:AlternateContent xmlns:mc="http://schemas.openxmlformats.org/markup-compatibility/2006">
-        <mc:Choice xmlns:a14="http://schemas.microsoft.com/office/drawing/2010/main" Requires="a14">
+      <mc:AlternateContent xmlns:mc="http://schemas.openxmlformats.org/markup-compatibility/2006" xmlns:a14="http://schemas.microsoft.com/office/drawing/2010/main">
+        <mc:Choice Requires="a14">
           <p:sp>
             <p:nvSpPr>
               <p:cNvPr id="14" name="TextBox 13">
@@ -10240,7 +10247,7 @@
             </p:txBody>
           </p:sp>
         </mc:Choice>
-        <mc:Fallback>
+        <mc:Fallback xmlns="">
           <p:sp>
             <p:nvSpPr>
               <p:cNvPr id="14" name="TextBox 13">
@@ -10285,8 +10292,8 @@
           </p:sp>
         </mc:Fallback>
       </mc:AlternateContent>
-      <mc:AlternateContent xmlns:mc="http://schemas.openxmlformats.org/markup-compatibility/2006">
-        <mc:Choice xmlns:a14="http://schemas.microsoft.com/office/drawing/2010/main" Requires="a14">
+      <mc:AlternateContent xmlns:mc="http://schemas.openxmlformats.org/markup-compatibility/2006" xmlns:a14="http://schemas.microsoft.com/office/drawing/2010/main">
+        <mc:Choice Requires="a14">
           <p:sp>
             <p:nvSpPr>
               <p:cNvPr id="16" name="TextBox 15">
@@ -10336,7 +10343,7 @@
             </p:txBody>
           </p:sp>
         </mc:Choice>
-        <mc:Fallback>
+        <mc:Fallback xmlns="">
           <p:sp>
             <p:nvSpPr>
               <p:cNvPr id="16" name="TextBox 15">
@@ -10605,8 +10612,8 @@
           </a:fontRef>
         </p:style>
       </p:cxnSp>
-      <mc:AlternateContent xmlns:mc="http://schemas.openxmlformats.org/markup-compatibility/2006">
-        <mc:Choice xmlns:a14="http://schemas.microsoft.com/office/drawing/2010/main" Requires="a14">
+      <mc:AlternateContent xmlns:mc="http://schemas.openxmlformats.org/markup-compatibility/2006" xmlns:a14="http://schemas.microsoft.com/office/drawing/2010/main">
+        <mc:Choice Requires="a14">
           <p:sp>
             <p:nvSpPr>
               <p:cNvPr id="57" name="TextBox 56">
@@ -10675,7 +10682,7 @@
             </p:txBody>
           </p:sp>
         </mc:Choice>
-        <mc:Fallback>
+        <mc:Fallback xmlns="">
           <p:sp>
             <p:nvSpPr>
               <p:cNvPr id="57" name="TextBox 56">
@@ -11048,8 +11055,8 @@
           </a:p>
         </p:txBody>
       </p:sp>
-      <mc:AlternateContent xmlns:mc="http://schemas.openxmlformats.org/markup-compatibility/2006">
-        <mc:Choice xmlns:a14="http://schemas.microsoft.com/office/drawing/2010/main" Requires="a14">
+      <mc:AlternateContent xmlns:mc="http://schemas.openxmlformats.org/markup-compatibility/2006" xmlns:a14="http://schemas.microsoft.com/office/drawing/2010/main">
+        <mc:Choice Requires="a14">
           <p:sp>
             <p:nvSpPr>
               <p:cNvPr id="15" name="TextBox 14">
@@ -11078,6 +11085,7 @@
               </a:bodyPr>
               <a:lstStyle/>
               <a:p>
+                <a:pPr/>
                 <a14:m>
                   <m:oMathPara xmlns:m="http://schemas.openxmlformats.org/officeDocument/2006/math">
                     <m:oMathParaPr>
@@ -11160,7 +11168,7 @@
             </p:txBody>
           </p:sp>
         </mc:Choice>
-        <mc:Fallback>
+        <mc:Fallback xmlns="">
           <p:sp>
             <p:nvSpPr>
               <p:cNvPr id="15" name="TextBox 14">
@@ -11205,8 +11213,8 @@
           </p:sp>
         </mc:Fallback>
       </mc:AlternateContent>
-      <mc:AlternateContent xmlns:mc="http://schemas.openxmlformats.org/markup-compatibility/2006">
-        <mc:Choice xmlns:a14="http://schemas.microsoft.com/office/drawing/2010/main" Requires="a14">
+      <mc:AlternateContent xmlns:mc="http://schemas.openxmlformats.org/markup-compatibility/2006" xmlns:a14="http://schemas.microsoft.com/office/drawing/2010/main">
+        <mc:Choice Requires="a14">
           <p:sp>
             <p:nvSpPr>
               <p:cNvPr id="20" name="TextBox 19">
@@ -11426,7 +11434,7 @@
             </p:txBody>
           </p:sp>
         </mc:Choice>
-        <mc:Fallback>
+        <mc:Fallback xmlns="">
           <p:sp>
             <p:nvSpPr>
               <p:cNvPr id="20" name="TextBox 19">
@@ -11471,8 +11479,8 @@
           </p:sp>
         </mc:Fallback>
       </mc:AlternateContent>
-      <mc:AlternateContent xmlns:mc="http://schemas.openxmlformats.org/markup-compatibility/2006">
-        <mc:Choice xmlns:a14="http://schemas.microsoft.com/office/drawing/2010/main" Requires="a14">
+      <mc:AlternateContent xmlns:mc="http://schemas.openxmlformats.org/markup-compatibility/2006" xmlns:a14="http://schemas.microsoft.com/office/drawing/2010/main">
+        <mc:Choice Requires="a14">
           <p:sp>
             <p:nvSpPr>
               <p:cNvPr id="35" name="TextBox 34">
@@ -11547,7 +11555,7 @@
             </p:txBody>
           </p:sp>
         </mc:Choice>
-        <mc:Fallback>
+        <mc:Fallback xmlns="">
           <p:sp>
             <p:nvSpPr>
               <p:cNvPr id="35" name="TextBox 34">
@@ -11893,8 +11901,8 @@
           </a:fontRef>
         </p:style>
       </p:cxnSp>
-      <mc:AlternateContent xmlns:mc="http://schemas.openxmlformats.org/markup-compatibility/2006">
-        <mc:Choice xmlns:a14="http://schemas.microsoft.com/office/drawing/2010/main" Requires="a14">
+      <mc:AlternateContent xmlns:mc="http://schemas.openxmlformats.org/markup-compatibility/2006" xmlns:a14="http://schemas.microsoft.com/office/drawing/2010/main">
+        <mc:Choice Requires="a14">
           <p:sp>
             <p:nvSpPr>
               <p:cNvPr id="12" name="TextBox 11">
@@ -11944,7 +11952,7 @@
             </p:txBody>
           </p:sp>
         </mc:Choice>
-        <mc:Fallback>
+        <mc:Fallback xmlns="">
           <p:sp>
             <p:nvSpPr>
               <p:cNvPr id="12" name="TextBox 11">
@@ -11989,8 +11997,8 @@
           </p:sp>
         </mc:Fallback>
       </mc:AlternateContent>
-      <mc:AlternateContent xmlns:mc="http://schemas.openxmlformats.org/markup-compatibility/2006">
-        <mc:Choice xmlns:a14="http://schemas.microsoft.com/office/drawing/2010/main" Requires="a14">
+      <mc:AlternateContent xmlns:mc="http://schemas.openxmlformats.org/markup-compatibility/2006" xmlns:a14="http://schemas.microsoft.com/office/drawing/2010/main">
+        <mc:Choice Requires="a14">
           <p:sp>
             <p:nvSpPr>
               <p:cNvPr id="14" name="TextBox 13">
@@ -12040,7 +12048,7 @@
             </p:txBody>
           </p:sp>
         </mc:Choice>
-        <mc:Fallback>
+        <mc:Fallback xmlns="">
           <p:sp>
             <p:nvSpPr>
               <p:cNvPr id="14" name="TextBox 13">
@@ -12085,8 +12093,8 @@
           </p:sp>
         </mc:Fallback>
       </mc:AlternateContent>
-      <mc:AlternateContent xmlns:mc="http://schemas.openxmlformats.org/markup-compatibility/2006">
-        <mc:Choice xmlns:a14="http://schemas.microsoft.com/office/drawing/2010/main" Requires="a14">
+      <mc:AlternateContent xmlns:mc="http://schemas.openxmlformats.org/markup-compatibility/2006" xmlns:a14="http://schemas.microsoft.com/office/drawing/2010/main">
+        <mc:Choice Requires="a14">
           <p:sp>
             <p:nvSpPr>
               <p:cNvPr id="16" name="TextBox 15">
@@ -12136,7 +12144,7 @@
             </p:txBody>
           </p:sp>
         </mc:Choice>
-        <mc:Fallback>
+        <mc:Fallback xmlns="">
           <p:sp>
             <p:nvSpPr>
               <p:cNvPr id="16" name="TextBox 15">
@@ -12405,8 +12413,8 @@
           </a:fontRef>
         </p:style>
       </p:cxnSp>
-      <mc:AlternateContent xmlns:mc="http://schemas.openxmlformats.org/markup-compatibility/2006">
-        <mc:Choice xmlns:a14="http://schemas.microsoft.com/office/drawing/2010/main" Requires="a14">
+      <mc:AlternateContent xmlns:mc="http://schemas.openxmlformats.org/markup-compatibility/2006" xmlns:a14="http://schemas.microsoft.com/office/drawing/2010/main">
+        <mc:Choice Requires="a14">
           <p:sp>
             <p:nvSpPr>
               <p:cNvPr id="57" name="TextBox 56">
@@ -12475,7 +12483,7 @@
             </p:txBody>
           </p:sp>
         </mc:Choice>
-        <mc:Fallback>
+        <mc:Fallback xmlns="">
           <p:sp>
             <p:nvSpPr>
               <p:cNvPr id="57" name="TextBox 56">
@@ -12848,8 +12856,8 @@
           </a:p>
         </p:txBody>
       </p:sp>
-      <mc:AlternateContent xmlns:mc="http://schemas.openxmlformats.org/markup-compatibility/2006">
-        <mc:Choice xmlns:a14="http://schemas.microsoft.com/office/drawing/2010/main" Requires="a14">
+      <mc:AlternateContent xmlns:mc="http://schemas.openxmlformats.org/markup-compatibility/2006" xmlns:a14="http://schemas.microsoft.com/office/drawing/2010/main">
+        <mc:Choice Requires="a14">
           <p:sp>
             <p:nvSpPr>
               <p:cNvPr id="15" name="TextBox 14">
@@ -12878,6 +12886,7 @@
               </a:bodyPr>
               <a:lstStyle/>
               <a:p>
+                <a:pPr/>
                 <a14:m>
                   <m:oMathPara xmlns:m="http://schemas.openxmlformats.org/officeDocument/2006/math">
                     <m:oMathParaPr>
@@ -12960,7 +12969,7 @@
             </p:txBody>
           </p:sp>
         </mc:Choice>
-        <mc:Fallback>
+        <mc:Fallback xmlns="">
           <p:sp>
             <p:nvSpPr>
               <p:cNvPr id="15" name="TextBox 14">
@@ -13005,8 +13014,8 @@
           </p:sp>
         </mc:Fallback>
       </mc:AlternateContent>
-      <mc:AlternateContent xmlns:mc="http://schemas.openxmlformats.org/markup-compatibility/2006">
-        <mc:Choice xmlns:a14="http://schemas.microsoft.com/office/drawing/2010/main" Requires="a14">
+      <mc:AlternateContent xmlns:mc="http://schemas.openxmlformats.org/markup-compatibility/2006" xmlns:a14="http://schemas.microsoft.com/office/drawing/2010/main">
+        <mc:Choice Requires="a14">
           <p:sp>
             <p:nvSpPr>
               <p:cNvPr id="20" name="TextBox 19">
@@ -13226,7 +13235,7 @@
             </p:txBody>
           </p:sp>
         </mc:Choice>
-        <mc:Fallback>
+        <mc:Fallback xmlns="">
           <p:sp>
             <p:nvSpPr>
               <p:cNvPr id="20" name="TextBox 19">
@@ -13271,8 +13280,8 @@
           </p:sp>
         </mc:Fallback>
       </mc:AlternateContent>
-      <mc:AlternateContent xmlns:mc="http://schemas.openxmlformats.org/markup-compatibility/2006">
-        <mc:Choice xmlns:a14="http://schemas.microsoft.com/office/drawing/2010/main" Requires="a14">
+      <mc:AlternateContent xmlns:mc="http://schemas.openxmlformats.org/markup-compatibility/2006" xmlns:a14="http://schemas.microsoft.com/office/drawing/2010/main">
+        <mc:Choice Requires="a14">
           <p:sp>
             <p:nvSpPr>
               <p:cNvPr id="21" name="TextBox 20">
@@ -13372,13 +13381,7 @@
                           <a:latin typeface="Cambria Math" panose="02040503050406030204" pitchFamily="18" charset="0"/>
                           <a:ea typeface="Cambria Math" panose="02040503050406030204" pitchFamily="18" charset="0"/>
                         </a:rPr>
-                        <m:t>𝜌</m:t>
-                      </m:r>
-                      <m:r>
-                        <a:rPr lang="en-US" sz="2800" i="1">
-                          <a:latin typeface="Cambria Math" panose="02040503050406030204" pitchFamily="18" charset="0"/>
-                        </a:rPr>
-                        <m:t>𝜓</m:t>
+                        <m:t>𝜌𝜓</m:t>
                       </m:r>
                     </m:oMath>
                   </m:oMathPara>
@@ -13388,7 +13391,7 @@
             </p:txBody>
           </p:sp>
         </mc:Choice>
-        <mc:Fallback>
+        <mc:Fallback xmlns="">
           <p:sp>
             <p:nvSpPr>
               <p:cNvPr id="21" name="TextBox 20">
@@ -13433,8 +13436,8 @@
           </p:sp>
         </mc:Fallback>
       </mc:AlternateContent>
-      <mc:AlternateContent xmlns:mc="http://schemas.openxmlformats.org/markup-compatibility/2006">
-        <mc:Choice xmlns:a14="http://schemas.microsoft.com/office/drawing/2010/main" Requires="a14">
+      <mc:AlternateContent xmlns:mc="http://schemas.openxmlformats.org/markup-compatibility/2006" xmlns:a14="http://schemas.microsoft.com/office/drawing/2010/main">
+        <mc:Choice Requires="a14">
           <p:sp>
             <p:nvSpPr>
               <p:cNvPr id="24" name="TextBox 23">
@@ -13500,7 +13503,7 @@
             </p:txBody>
           </p:sp>
         </mc:Choice>
-        <mc:Fallback>
+        <mc:Fallback xmlns="">
           <p:sp>
             <p:nvSpPr>
               <p:cNvPr id="24" name="TextBox 23">
@@ -13545,8 +13548,8 @@
           </p:sp>
         </mc:Fallback>
       </mc:AlternateContent>
-      <mc:AlternateContent xmlns:mc="http://schemas.openxmlformats.org/markup-compatibility/2006">
-        <mc:Choice xmlns:a14="http://schemas.microsoft.com/office/drawing/2010/main" Requires="a14">
+      <mc:AlternateContent xmlns:mc="http://schemas.openxmlformats.org/markup-compatibility/2006" xmlns:a14="http://schemas.microsoft.com/office/drawing/2010/main">
+        <mc:Choice Requires="a14">
           <p:sp>
             <p:nvSpPr>
               <p:cNvPr id="26" name="TextBox 25">
@@ -13636,7 +13639,7 @@
             </p:txBody>
           </p:sp>
         </mc:Choice>
-        <mc:Fallback>
+        <mc:Fallback xmlns="">
           <p:sp>
             <p:nvSpPr>
               <p:cNvPr id="26" name="TextBox 25">
@@ -13681,8 +13684,8 @@
           </p:sp>
         </mc:Fallback>
       </mc:AlternateContent>
-      <mc:AlternateContent xmlns:mc="http://schemas.openxmlformats.org/markup-compatibility/2006">
-        <mc:Choice xmlns:a14="http://schemas.microsoft.com/office/drawing/2010/main" Requires="a14">
+      <mc:AlternateContent xmlns:mc="http://schemas.openxmlformats.org/markup-compatibility/2006" xmlns:a14="http://schemas.microsoft.com/office/drawing/2010/main">
+        <mc:Choice Requires="a14">
           <p:sp>
             <p:nvSpPr>
               <p:cNvPr id="30" name="TextBox 29">
@@ -13773,7 +13776,7 @@
             </p:txBody>
           </p:sp>
         </mc:Choice>
-        <mc:Fallback>
+        <mc:Fallback xmlns="">
           <p:sp>
             <p:nvSpPr>
               <p:cNvPr id="30" name="TextBox 29">
@@ -13818,8 +13821,8 @@
           </p:sp>
         </mc:Fallback>
       </mc:AlternateContent>
-      <mc:AlternateContent xmlns:mc="http://schemas.openxmlformats.org/markup-compatibility/2006">
-        <mc:Choice xmlns:a14="http://schemas.microsoft.com/office/drawing/2010/main" Requires="a14">
+      <mc:AlternateContent xmlns:mc="http://schemas.openxmlformats.org/markup-compatibility/2006" xmlns:a14="http://schemas.microsoft.com/office/drawing/2010/main">
+        <mc:Choice Requires="a14">
           <p:sp>
             <p:nvSpPr>
               <p:cNvPr id="33" name="TextBox 32">
@@ -13894,7 +13897,7 @@
             </p:txBody>
           </p:sp>
         </mc:Choice>
-        <mc:Fallback>
+        <mc:Fallback xmlns="">
           <p:sp>
             <p:nvSpPr>
               <p:cNvPr id="33" name="TextBox 32">
@@ -14348,8 +14351,8 @@
           </a:fontRef>
         </p:style>
       </p:cxnSp>
-      <mc:AlternateContent xmlns:mc="http://schemas.openxmlformats.org/markup-compatibility/2006">
-        <mc:Choice xmlns:a14="http://schemas.microsoft.com/office/drawing/2010/main" Requires="a14">
+      <mc:AlternateContent xmlns:mc="http://schemas.openxmlformats.org/markup-compatibility/2006" xmlns:a14="http://schemas.microsoft.com/office/drawing/2010/main">
+        <mc:Choice Requires="a14">
           <p:sp>
             <p:nvSpPr>
               <p:cNvPr id="12" name="TextBox 11">
@@ -14399,7 +14402,7 @@
             </p:txBody>
           </p:sp>
         </mc:Choice>
-        <mc:Fallback>
+        <mc:Fallback xmlns="">
           <p:sp>
             <p:nvSpPr>
               <p:cNvPr id="12" name="TextBox 11">
@@ -14444,8 +14447,8 @@
           </p:sp>
         </mc:Fallback>
       </mc:AlternateContent>
-      <mc:AlternateContent xmlns:mc="http://schemas.openxmlformats.org/markup-compatibility/2006">
-        <mc:Choice xmlns:a14="http://schemas.microsoft.com/office/drawing/2010/main" Requires="a14">
+      <mc:AlternateContent xmlns:mc="http://schemas.openxmlformats.org/markup-compatibility/2006" xmlns:a14="http://schemas.microsoft.com/office/drawing/2010/main">
+        <mc:Choice Requires="a14">
           <p:sp>
             <p:nvSpPr>
               <p:cNvPr id="14" name="TextBox 13">
@@ -14495,7 +14498,7 @@
             </p:txBody>
           </p:sp>
         </mc:Choice>
-        <mc:Fallback>
+        <mc:Fallback xmlns="">
           <p:sp>
             <p:nvSpPr>
               <p:cNvPr id="14" name="TextBox 13">
@@ -14540,8 +14543,8 @@
           </p:sp>
         </mc:Fallback>
       </mc:AlternateContent>
-      <mc:AlternateContent xmlns:mc="http://schemas.openxmlformats.org/markup-compatibility/2006">
-        <mc:Choice xmlns:a14="http://schemas.microsoft.com/office/drawing/2010/main" Requires="a14">
+      <mc:AlternateContent xmlns:mc="http://schemas.openxmlformats.org/markup-compatibility/2006" xmlns:a14="http://schemas.microsoft.com/office/drawing/2010/main">
+        <mc:Choice Requires="a14">
           <p:sp>
             <p:nvSpPr>
               <p:cNvPr id="16" name="TextBox 15">
@@ -14591,7 +14594,7 @@
             </p:txBody>
           </p:sp>
         </mc:Choice>
-        <mc:Fallback>
+        <mc:Fallback xmlns="">
           <p:sp>
             <p:nvSpPr>
               <p:cNvPr id="16" name="TextBox 15">
@@ -14860,8 +14863,8 @@
           </a:fontRef>
         </p:style>
       </p:cxnSp>
-      <mc:AlternateContent xmlns:mc="http://schemas.openxmlformats.org/markup-compatibility/2006">
-        <mc:Choice xmlns:a14="http://schemas.microsoft.com/office/drawing/2010/main" Requires="a14">
+      <mc:AlternateContent xmlns:mc="http://schemas.openxmlformats.org/markup-compatibility/2006" xmlns:a14="http://schemas.microsoft.com/office/drawing/2010/main">
+        <mc:Choice Requires="a14">
           <p:sp>
             <p:nvSpPr>
               <p:cNvPr id="57" name="TextBox 56">
@@ -14930,7 +14933,7 @@
             </p:txBody>
           </p:sp>
         </mc:Choice>
-        <mc:Fallback>
+        <mc:Fallback xmlns="">
           <p:sp>
             <p:nvSpPr>
               <p:cNvPr id="57" name="TextBox 56">
@@ -15303,8 +15306,8 @@
           </a:p>
         </p:txBody>
       </p:sp>
-      <mc:AlternateContent xmlns:mc="http://schemas.openxmlformats.org/markup-compatibility/2006">
-        <mc:Choice xmlns:a14="http://schemas.microsoft.com/office/drawing/2010/main" Requires="a14">
+      <mc:AlternateContent xmlns:mc="http://schemas.openxmlformats.org/markup-compatibility/2006" xmlns:a14="http://schemas.microsoft.com/office/drawing/2010/main">
+        <mc:Choice Requires="a14">
           <p:sp>
             <p:nvSpPr>
               <p:cNvPr id="15" name="TextBox 14">
@@ -15333,6 +15336,7 @@
               </a:bodyPr>
               <a:lstStyle/>
               <a:p>
+                <a:pPr/>
                 <a14:m>
                   <m:oMathPara xmlns:m="http://schemas.openxmlformats.org/officeDocument/2006/math">
                     <m:oMathParaPr>
@@ -15415,7 +15419,7 @@
             </p:txBody>
           </p:sp>
         </mc:Choice>
-        <mc:Fallback>
+        <mc:Fallback xmlns="">
           <p:sp>
             <p:nvSpPr>
               <p:cNvPr id="15" name="TextBox 14">
@@ -15460,8 +15464,8 @@
           </p:sp>
         </mc:Fallback>
       </mc:AlternateContent>
-      <mc:AlternateContent xmlns:mc="http://schemas.openxmlformats.org/markup-compatibility/2006">
-        <mc:Choice xmlns:a14="http://schemas.microsoft.com/office/drawing/2010/main" Requires="a14">
+      <mc:AlternateContent xmlns:mc="http://schemas.openxmlformats.org/markup-compatibility/2006" xmlns:a14="http://schemas.microsoft.com/office/drawing/2010/main">
+        <mc:Choice Requires="a14">
           <p:sp>
             <p:nvSpPr>
               <p:cNvPr id="20" name="TextBox 19">
@@ -15681,7 +15685,7 @@
             </p:txBody>
           </p:sp>
         </mc:Choice>
-        <mc:Fallback>
+        <mc:Fallback xmlns="">
           <p:sp>
             <p:nvSpPr>
               <p:cNvPr id="20" name="TextBox 19">
@@ -15726,8 +15730,8 @@
           </p:sp>
         </mc:Fallback>
       </mc:AlternateContent>
-      <mc:AlternateContent xmlns:mc="http://schemas.openxmlformats.org/markup-compatibility/2006">
-        <mc:Choice xmlns:a14="http://schemas.microsoft.com/office/drawing/2010/main" Requires="a14">
+      <mc:AlternateContent xmlns:mc="http://schemas.openxmlformats.org/markup-compatibility/2006" xmlns:a14="http://schemas.microsoft.com/office/drawing/2010/main">
+        <mc:Choice Requires="a14">
           <p:sp>
             <p:nvSpPr>
               <p:cNvPr id="21" name="TextBox 20">
@@ -15827,13 +15831,7 @@
                           <a:latin typeface="Cambria Math" panose="02040503050406030204" pitchFamily="18" charset="0"/>
                           <a:ea typeface="Cambria Math" panose="02040503050406030204" pitchFamily="18" charset="0"/>
                         </a:rPr>
-                        <m:t>𝜌</m:t>
-                      </m:r>
-                      <m:r>
-                        <a:rPr lang="en-US" sz="2800" i="1">
-                          <a:latin typeface="Cambria Math" panose="02040503050406030204" pitchFamily="18" charset="0"/>
-                        </a:rPr>
-                        <m:t>𝜓</m:t>
+                        <m:t>𝜌𝜓</m:t>
                       </m:r>
                     </m:oMath>
                   </m:oMathPara>
@@ -15843,7 +15841,7 @@
             </p:txBody>
           </p:sp>
         </mc:Choice>
-        <mc:Fallback>
+        <mc:Fallback xmlns="">
           <p:sp>
             <p:nvSpPr>
               <p:cNvPr id="21" name="TextBox 20">
@@ -15888,8 +15886,8 @@
           </p:sp>
         </mc:Fallback>
       </mc:AlternateContent>
-      <mc:AlternateContent xmlns:mc="http://schemas.openxmlformats.org/markup-compatibility/2006">
-        <mc:Choice xmlns:a14="http://schemas.microsoft.com/office/drawing/2010/main" Requires="a14">
+      <mc:AlternateContent xmlns:mc="http://schemas.openxmlformats.org/markup-compatibility/2006" xmlns:a14="http://schemas.microsoft.com/office/drawing/2010/main">
+        <mc:Choice Requires="a14">
           <p:sp>
             <p:nvSpPr>
               <p:cNvPr id="24" name="TextBox 23">
@@ -15955,7 +15953,7 @@
             </p:txBody>
           </p:sp>
         </mc:Choice>
-        <mc:Fallback>
+        <mc:Fallback xmlns="">
           <p:sp>
             <p:nvSpPr>
               <p:cNvPr id="24" name="TextBox 23">
@@ -16000,8 +15998,8 @@
           </p:sp>
         </mc:Fallback>
       </mc:AlternateContent>
-      <mc:AlternateContent xmlns:mc="http://schemas.openxmlformats.org/markup-compatibility/2006">
-        <mc:Choice xmlns:a14="http://schemas.microsoft.com/office/drawing/2010/main" Requires="a14">
+      <mc:AlternateContent xmlns:mc="http://schemas.openxmlformats.org/markup-compatibility/2006" xmlns:a14="http://schemas.microsoft.com/office/drawing/2010/main">
+        <mc:Choice Requires="a14">
           <p:sp>
             <p:nvSpPr>
               <p:cNvPr id="26" name="TextBox 25">
@@ -16091,7 +16089,7 @@
             </p:txBody>
           </p:sp>
         </mc:Choice>
-        <mc:Fallback>
+        <mc:Fallback xmlns="">
           <p:sp>
             <p:nvSpPr>
               <p:cNvPr id="26" name="TextBox 25">
@@ -16136,8 +16134,8 @@
           </p:sp>
         </mc:Fallback>
       </mc:AlternateContent>
-      <mc:AlternateContent xmlns:mc="http://schemas.openxmlformats.org/markup-compatibility/2006">
-        <mc:Choice xmlns:a14="http://schemas.microsoft.com/office/drawing/2010/main" Requires="a14">
+      <mc:AlternateContent xmlns:mc="http://schemas.openxmlformats.org/markup-compatibility/2006" xmlns:a14="http://schemas.microsoft.com/office/drawing/2010/main">
+        <mc:Choice Requires="a14">
           <p:sp>
             <p:nvSpPr>
               <p:cNvPr id="27" name="TextBox 26">
@@ -16228,7 +16226,7 @@
             </p:txBody>
           </p:sp>
         </mc:Choice>
-        <mc:Fallback>
+        <mc:Fallback xmlns="">
           <p:sp>
             <p:nvSpPr>
               <p:cNvPr id="27" name="TextBox 26">
@@ -16273,8 +16271,8 @@
           </p:sp>
         </mc:Fallback>
       </mc:AlternateContent>
-      <mc:AlternateContent xmlns:mc="http://schemas.openxmlformats.org/markup-compatibility/2006">
-        <mc:Choice xmlns:a14="http://schemas.microsoft.com/office/drawing/2010/main" Requires="a14">
+      <mc:AlternateContent xmlns:mc="http://schemas.openxmlformats.org/markup-compatibility/2006" xmlns:a14="http://schemas.microsoft.com/office/drawing/2010/main">
+        <mc:Choice Requires="a14">
           <p:sp>
             <p:nvSpPr>
               <p:cNvPr id="28" name="TextBox 27">
@@ -16406,7 +16404,7 @@
             </p:txBody>
           </p:sp>
         </mc:Choice>
-        <mc:Fallback>
+        <mc:Fallback xmlns="">
           <p:sp>
             <p:nvSpPr>
               <p:cNvPr id="28" name="TextBox 27">
@@ -16533,8 +16531,8 @@
           </a:fontRef>
         </p:style>
       </p:cxnSp>
-      <mc:AlternateContent xmlns:mc="http://schemas.openxmlformats.org/markup-compatibility/2006">
-        <mc:Choice xmlns:a14="http://schemas.microsoft.com/office/drawing/2010/main" Requires="a14">
+      <mc:AlternateContent xmlns:mc="http://schemas.openxmlformats.org/markup-compatibility/2006" xmlns:a14="http://schemas.microsoft.com/office/drawing/2010/main">
+        <mc:Choice Requires="a14">
           <p:sp>
             <p:nvSpPr>
               <p:cNvPr id="22" name="TextBox 21">
@@ -16606,7 +16604,7 @@
             </p:txBody>
           </p:sp>
         </mc:Choice>
-        <mc:Fallback>
+        <mc:Fallback xmlns="">
           <p:sp>
             <p:nvSpPr>
               <p:cNvPr id="22" name="TextBox 21">
@@ -16651,8 +16649,8 @@
           </p:sp>
         </mc:Fallback>
       </mc:AlternateContent>
-      <mc:AlternateContent xmlns:mc="http://schemas.openxmlformats.org/markup-compatibility/2006">
-        <mc:Choice xmlns:a14="http://schemas.microsoft.com/office/drawing/2010/main" Requires="a14">
+      <mc:AlternateContent xmlns:mc="http://schemas.openxmlformats.org/markup-compatibility/2006" xmlns:a14="http://schemas.microsoft.com/office/drawing/2010/main">
+        <mc:Choice Requires="a14">
           <p:sp>
             <p:nvSpPr>
               <p:cNvPr id="33" name="TextBox 32">
@@ -16727,7 +16725,7 @@
             </p:txBody>
           </p:sp>
         </mc:Choice>
-        <mc:Fallback>
+        <mc:Fallback xmlns="">
           <p:sp>
             <p:nvSpPr>
               <p:cNvPr id="33" name="TextBox 32">
@@ -17181,8 +17179,8 @@
           </a:fontRef>
         </p:style>
       </p:cxnSp>
-      <mc:AlternateContent xmlns:mc="http://schemas.openxmlformats.org/markup-compatibility/2006">
-        <mc:Choice xmlns:a14="http://schemas.microsoft.com/office/drawing/2010/main" Requires="a14">
+      <mc:AlternateContent xmlns:mc="http://schemas.openxmlformats.org/markup-compatibility/2006" xmlns:a14="http://schemas.microsoft.com/office/drawing/2010/main">
+        <mc:Choice Requires="a14">
           <p:sp>
             <p:nvSpPr>
               <p:cNvPr id="12" name="TextBox 11">
@@ -17232,7 +17230,7 @@
             </p:txBody>
           </p:sp>
         </mc:Choice>
-        <mc:Fallback>
+        <mc:Fallback xmlns="">
           <p:sp>
             <p:nvSpPr>
               <p:cNvPr id="12" name="TextBox 11">
@@ -17277,8 +17275,8 @@
           </p:sp>
         </mc:Fallback>
       </mc:AlternateContent>
-      <mc:AlternateContent xmlns:mc="http://schemas.openxmlformats.org/markup-compatibility/2006">
-        <mc:Choice xmlns:a14="http://schemas.microsoft.com/office/drawing/2010/main" Requires="a14">
+      <mc:AlternateContent xmlns:mc="http://schemas.openxmlformats.org/markup-compatibility/2006" xmlns:a14="http://schemas.microsoft.com/office/drawing/2010/main">
+        <mc:Choice Requires="a14">
           <p:sp>
             <p:nvSpPr>
               <p:cNvPr id="14" name="TextBox 13">
@@ -17328,7 +17326,7 @@
             </p:txBody>
           </p:sp>
         </mc:Choice>
-        <mc:Fallback>
+        <mc:Fallback xmlns="">
           <p:sp>
             <p:nvSpPr>
               <p:cNvPr id="14" name="TextBox 13">
@@ -17373,8 +17371,8 @@
           </p:sp>
         </mc:Fallback>
       </mc:AlternateContent>
-      <mc:AlternateContent xmlns:mc="http://schemas.openxmlformats.org/markup-compatibility/2006">
-        <mc:Choice xmlns:a14="http://schemas.microsoft.com/office/drawing/2010/main" Requires="a14">
+      <mc:AlternateContent xmlns:mc="http://schemas.openxmlformats.org/markup-compatibility/2006" xmlns:a14="http://schemas.microsoft.com/office/drawing/2010/main">
+        <mc:Choice Requires="a14">
           <p:sp>
             <p:nvSpPr>
               <p:cNvPr id="16" name="TextBox 15">
@@ -17424,7 +17422,7 @@
             </p:txBody>
           </p:sp>
         </mc:Choice>
-        <mc:Fallback>
+        <mc:Fallback xmlns="">
           <p:sp>
             <p:nvSpPr>
               <p:cNvPr id="16" name="TextBox 15">
@@ -17693,8 +17691,8 @@
           </a:fontRef>
         </p:style>
       </p:cxnSp>
-      <mc:AlternateContent xmlns:mc="http://schemas.openxmlformats.org/markup-compatibility/2006">
-        <mc:Choice xmlns:a14="http://schemas.microsoft.com/office/drawing/2010/main" Requires="a14">
+      <mc:AlternateContent xmlns:mc="http://schemas.openxmlformats.org/markup-compatibility/2006" xmlns:a14="http://schemas.microsoft.com/office/drawing/2010/main">
+        <mc:Choice Requires="a14">
           <p:sp>
             <p:nvSpPr>
               <p:cNvPr id="57" name="TextBox 56">
@@ -17763,7 +17761,7 @@
             </p:txBody>
           </p:sp>
         </mc:Choice>
-        <mc:Fallback>
+        <mc:Fallback xmlns="">
           <p:sp>
             <p:nvSpPr>
               <p:cNvPr id="57" name="TextBox 56">
@@ -18136,8 +18134,8 @@
           </a:p>
         </p:txBody>
       </p:sp>
-      <mc:AlternateContent xmlns:mc="http://schemas.openxmlformats.org/markup-compatibility/2006">
-        <mc:Choice xmlns:a14="http://schemas.microsoft.com/office/drawing/2010/main" Requires="a14">
+      <mc:AlternateContent xmlns:mc="http://schemas.openxmlformats.org/markup-compatibility/2006" xmlns:a14="http://schemas.microsoft.com/office/drawing/2010/main">
+        <mc:Choice Requires="a14">
           <p:sp>
             <p:nvSpPr>
               <p:cNvPr id="15" name="TextBox 14">
@@ -18166,6 +18164,7 @@
               </a:bodyPr>
               <a:lstStyle/>
               <a:p>
+                <a:pPr/>
                 <a14:m>
                   <m:oMathPara xmlns:m="http://schemas.openxmlformats.org/officeDocument/2006/math">
                     <m:oMathParaPr>
@@ -18248,7 +18247,7 @@
             </p:txBody>
           </p:sp>
         </mc:Choice>
-        <mc:Fallback>
+        <mc:Fallback xmlns="">
           <p:sp>
             <p:nvSpPr>
               <p:cNvPr id="15" name="TextBox 14">
@@ -18293,8 +18292,8 @@
           </p:sp>
         </mc:Fallback>
       </mc:AlternateContent>
-      <mc:AlternateContent xmlns:mc="http://schemas.openxmlformats.org/markup-compatibility/2006">
-        <mc:Choice xmlns:a14="http://schemas.microsoft.com/office/drawing/2010/main" Requires="a14">
+      <mc:AlternateContent xmlns:mc="http://schemas.openxmlformats.org/markup-compatibility/2006" xmlns:a14="http://schemas.microsoft.com/office/drawing/2010/main">
+        <mc:Choice Requires="a14">
           <p:sp>
             <p:nvSpPr>
               <p:cNvPr id="20" name="TextBox 19">
@@ -18514,7 +18513,7 @@
             </p:txBody>
           </p:sp>
         </mc:Choice>
-        <mc:Fallback>
+        <mc:Fallback xmlns="">
           <p:sp>
             <p:nvSpPr>
               <p:cNvPr id="20" name="TextBox 19">
@@ -18559,8 +18558,8 @@
           </p:sp>
         </mc:Fallback>
       </mc:AlternateContent>
-      <mc:AlternateContent xmlns:mc="http://schemas.openxmlformats.org/markup-compatibility/2006">
-        <mc:Choice xmlns:a14="http://schemas.microsoft.com/office/drawing/2010/main" Requires="a14">
+      <mc:AlternateContent xmlns:mc="http://schemas.openxmlformats.org/markup-compatibility/2006" xmlns:a14="http://schemas.microsoft.com/office/drawing/2010/main">
+        <mc:Choice Requires="a14">
           <p:sp>
             <p:nvSpPr>
               <p:cNvPr id="21" name="TextBox 20">
@@ -18660,13 +18659,7 @@
                           <a:latin typeface="Cambria Math" panose="02040503050406030204" pitchFamily="18" charset="0"/>
                           <a:ea typeface="Cambria Math" panose="02040503050406030204" pitchFamily="18" charset="0"/>
                         </a:rPr>
-                        <m:t>𝜌</m:t>
-                      </m:r>
-                      <m:r>
-                        <a:rPr lang="en-US" sz="2800" i="1">
-                          <a:latin typeface="Cambria Math" panose="02040503050406030204" pitchFamily="18" charset="0"/>
-                        </a:rPr>
-                        <m:t>𝜓</m:t>
+                        <m:t>𝜌𝜓</m:t>
                       </m:r>
                     </m:oMath>
                   </m:oMathPara>
@@ -18676,7 +18669,7 @@
             </p:txBody>
           </p:sp>
         </mc:Choice>
-        <mc:Fallback>
+        <mc:Fallback xmlns="">
           <p:sp>
             <p:nvSpPr>
               <p:cNvPr id="21" name="TextBox 20">
@@ -18721,8 +18714,8 @@
           </p:sp>
         </mc:Fallback>
       </mc:AlternateContent>
-      <mc:AlternateContent xmlns:mc="http://schemas.openxmlformats.org/markup-compatibility/2006">
-        <mc:Choice xmlns:a14="http://schemas.microsoft.com/office/drawing/2010/main" Requires="a14">
+      <mc:AlternateContent xmlns:mc="http://schemas.openxmlformats.org/markup-compatibility/2006" xmlns:a14="http://schemas.microsoft.com/office/drawing/2010/main">
+        <mc:Choice Requires="a14">
           <p:sp>
             <p:nvSpPr>
               <p:cNvPr id="24" name="TextBox 23">
@@ -18788,7 +18781,7 @@
             </p:txBody>
           </p:sp>
         </mc:Choice>
-        <mc:Fallback>
+        <mc:Fallback xmlns="">
           <p:sp>
             <p:nvSpPr>
               <p:cNvPr id="24" name="TextBox 23">
@@ -18833,8 +18826,8 @@
           </p:sp>
         </mc:Fallback>
       </mc:AlternateContent>
-      <mc:AlternateContent xmlns:mc="http://schemas.openxmlformats.org/markup-compatibility/2006">
-        <mc:Choice xmlns:a14="http://schemas.microsoft.com/office/drawing/2010/main" Requires="a14">
+      <mc:AlternateContent xmlns:mc="http://schemas.openxmlformats.org/markup-compatibility/2006" xmlns:a14="http://schemas.microsoft.com/office/drawing/2010/main">
+        <mc:Choice Requires="a14">
           <p:sp>
             <p:nvSpPr>
               <p:cNvPr id="26" name="TextBox 25">
@@ -18924,7 +18917,7 @@
             </p:txBody>
           </p:sp>
         </mc:Choice>
-        <mc:Fallback>
+        <mc:Fallback xmlns="">
           <p:sp>
             <p:nvSpPr>
               <p:cNvPr id="26" name="TextBox 25">
@@ -18969,8 +18962,8 @@
           </p:sp>
         </mc:Fallback>
       </mc:AlternateContent>
-      <mc:AlternateContent xmlns:mc="http://schemas.openxmlformats.org/markup-compatibility/2006">
-        <mc:Choice xmlns:a14="http://schemas.microsoft.com/office/drawing/2010/main" Requires="a14">
+      <mc:AlternateContent xmlns:mc="http://schemas.openxmlformats.org/markup-compatibility/2006" xmlns:a14="http://schemas.microsoft.com/office/drawing/2010/main">
+        <mc:Choice Requires="a14">
           <p:sp>
             <p:nvSpPr>
               <p:cNvPr id="27" name="TextBox 26">
@@ -19061,7 +19054,7 @@
             </p:txBody>
           </p:sp>
         </mc:Choice>
-        <mc:Fallback>
+        <mc:Fallback xmlns="">
           <p:sp>
             <p:nvSpPr>
               <p:cNvPr id="27" name="TextBox 26">
@@ -19106,8 +19099,8 @@
           </p:sp>
         </mc:Fallback>
       </mc:AlternateContent>
-      <mc:AlternateContent xmlns:mc="http://schemas.openxmlformats.org/markup-compatibility/2006">
-        <mc:Choice xmlns:a14="http://schemas.microsoft.com/office/drawing/2010/main" Requires="a14">
+      <mc:AlternateContent xmlns:mc="http://schemas.openxmlformats.org/markup-compatibility/2006" xmlns:a14="http://schemas.microsoft.com/office/drawing/2010/main">
+        <mc:Choice Requires="a14">
           <p:sp>
             <p:nvSpPr>
               <p:cNvPr id="8" name="TextBox 7">
@@ -19136,6 +19129,7 @@
               </a:bodyPr>
               <a:lstStyle/>
               <a:p>
+                <a:pPr/>
                 <a14:m>
                   <m:oMathPara xmlns:m="http://schemas.openxmlformats.org/officeDocument/2006/math">
                     <m:oMathParaPr>
@@ -19212,7 +19206,7 @@
             </p:txBody>
           </p:sp>
         </mc:Choice>
-        <mc:Fallback>
+        <mc:Fallback xmlns="">
           <p:sp>
             <p:nvSpPr>
               <p:cNvPr id="8" name="TextBox 7">
@@ -19257,8 +19251,8 @@
           </p:sp>
         </mc:Fallback>
       </mc:AlternateContent>
-      <mc:AlternateContent xmlns:mc="http://schemas.openxmlformats.org/markup-compatibility/2006">
-        <mc:Choice xmlns:a14="http://schemas.microsoft.com/office/drawing/2010/main" Requires="a14">
+      <mc:AlternateContent xmlns:mc="http://schemas.openxmlformats.org/markup-compatibility/2006" xmlns:a14="http://schemas.microsoft.com/office/drawing/2010/main">
+        <mc:Choice Requires="a14">
           <p:sp>
             <p:nvSpPr>
               <p:cNvPr id="29" name="TextBox 28">
@@ -19365,7 +19359,7 @@
             </p:txBody>
           </p:sp>
         </mc:Choice>
-        <mc:Fallback>
+        <mc:Fallback xmlns="">
           <p:sp>
             <p:nvSpPr>
               <p:cNvPr id="29" name="TextBox 28">
@@ -19451,8 +19445,8 @@
           </a:fontRef>
         </p:style>
       </p:cxnSp>
-      <mc:AlternateContent xmlns:mc="http://schemas.openxmlformats.org/markup-compatibility/2006">
-        <mc:Choice xmlns:a14="http://schemas.microsoft.com/office/drawing/2010/main" Requires="a14">
+      <mc:AlternateContent xmlns:mc="http://schemas.openxmlformats.org/markup-compatibility/2006" xmlns:a14="http://schemas.microsoft.com/office/drawing/2010/main">
+        <mc:Choice Requires="a14">
           <p:sp>
             <p:nvSpPr>
               <p:cNvPr id="38" name="TextBox 37">
@@ -19584,7 +19578,7 @@
             </p:txBody>
           </p:sp>
         </mc:Choice>
-        <mc:Fallback>
+        <mc:Fallback xmlns="">
           <p:sp>
             <p:nvSpPr>
               <p:cNvPr id="38" name="TextBox 37">
@@ -19670,8 +19664,8 @@
           </a:fontRef>
         </p:style>
       </p:cxnSp>
-      <mc:AlternateContent xmlns:mc="http://schemas.openxmlformats.org/markup-compatibility/2006">
-        <mc:Choice xmlns:a14="http://schemas.microsoft.com/office/drawing/2010/main" Requires="a14">
+      <mc:AlternateContent xmlns:mc="http://schemas.openxmlformats.org/markup-compatibility/2006" xmlns:a14="http://schemas.microsoft.com/office/drawing/2010/main">
+        <mc:Choice Requires="a14">
           <p:sp>
             <p:nvSpPr>
               <p:cNvPr id="42" name="TextBox 41">
@@ -19743,7 +19737,7 @@
             </p:txBody>
           </p:sp>
         </mc:Choice>
-        <mc:Fallback>
+        <mc:Fallback xmlns="">
           <p:sp>
             <p:nvSpPr>
               <p:cNvPr id="42" name="TextBox 41">
@@ -19788,8 +19782,8 @@
           </p:sp>
         </mc:Fallback>
       </mc:AlternateContent>
-      <mc:AlternateContent xmlns:mc="http://schemas.openxmlformats.org/markup-compatibility/2006">
-        <mc:Choice xmlns:a14="http://schemas.microsoft.com/office/drawing/2010/main" Requires="a14">
+      <mc:AlternateContent xmlns:mc="http://schemas.openxmlformats.org/markup-compatibility/2006" xmlns:a14="http://schemas.microsoft.com/office/drawing/2010/main">
+        <mc:Choice Requires="a14">
           <p:sp>
             <p:nvSpPr>
               <p:cNvPr id="44" name="TextBox 43">
@@ -19864,7 +19858,7 @@
             </p:txBody>
           </p:sp>
         </mc:Choice>
-        <mc:Fallback>
+        <mc:Fallback xmlns="">
           <p:sp>
             <p:nvSpPr>
               <p:cNvPr id="44" name="TextBox 43">
@@ -19939,8 +19933,8 @@
           <a:chExt cx="0" cy="0"/>
         </a:xfrm>
       </p:grpSpPr>
-      <mc:AlternateContent xmlns:mc="http://schemas.openxmlformats.org/markup-compatibility/2006">
-        <mc:Choice xmlns:a14="http://schemas.microsoft.com/office/drawing/2010/main" Requires="a14">
+      <mc:AlternateContent xmlns:mc="http://schemas.openxmlformats.org/markup-compatibility/2006" xmlns:a14="http://schemas.microsoft.com/office/drawing/2010/main">
+        <mc:Choice Requires="a14">
           <p:sp>
             <p:nvSpPr>
               <p:cNvPr id="2" name="TextBox 1">
@@ -20003,7 +19997,7 @@
             </p:txBody>
           </p:sp>
         </mc:Choice>
-        <mc:Fallback>
+        <mc:Fallback xmlns="">
           <p:sp>
             <p:nvSpPr>
               <p:cNvPr id="2" name="TextBox 1">
@@ -20027,7 +20021,7 @@
                 <a:avLst/>
               </a:prstGeom>
               <a:blipFill>
-                <a:blip r:embed="rId2"/>
+                <a:blip r:embed="rId3"/>
                 <a:stretch>
                   <a:fillRect l="-5639" t="-19289" r="-4737" b="-41117"/>
                 </a:stretch>
@@ -20591,87 +20585,6 @@
   <p:clrMapOvr>
     <a:masterClrMapping/>
   </p:clrMapOvr>
-  <p:timing>
-    <p:tnLst>
-      <p:par>
-        <p:cTn id="1" dur="indefinite" restart="never" nodeType="tmRoot">
-          <p:childTnLst>
-            <p:seq concurrent="1" nextAc="seek">
-              <p:cTn id="2" dur="indefinite" nodeType="mainSeq">
-                <p:childTnLst>
-                  <p:par>
-                    <p:cTn id="3" fill="hold">
-                      <p:stCondLst>
-                        <p:cond delay="indefinite"/>
-                        <p:cond evt="onBegin" delay="0">
-                          <p:tn val="2"/>
-                        </p:cond>
-                      </p:stCondLst>
-                      <p:childTnLst>
-                        <p:par>
-                          <p:cTn id="4" fill="hold">
-                            <p:stCondLst>
-                              <p:cond delay="0"/>
-                            </p:stCondLst>
-                            <p:childTnLst>
-                              <p:par>
-                                <p:cTn id="5" presetID="1" presetClass="entr" presetSubtype="0" fill="hold" grpId="0" nodeType="withEffect">
-                                  <p:stCondLst>
-                                    <p:cond delay="0"/>
-                                  </p:stCondLst>
-                                  <p:childTnLst>
-                                    <p:set>
-                                      <p:cBhvr>
-                                        <p:cTn id="6" dur="1" fill="hold">
-                                          <p:stCondLst>
-                                            <p:cond delay="0"/>
-                                          </p:stCondLst>
-                                        </p:cTn>
-                                        <p:tgtEl>
-                                          <p:spTgt spid="2"/>
-                                        </p:tgtEl>
-                                        <p:attrNameLst>
-                                          <p:attrName>style.visibility</p:attrName>
-                                        </p:attrNameLst>
-                                      </p:cBhvr>
-                                      <p:to>
-                                        <p:strVal val="visible"/>
-                                      </p:to>
-                                    </p:set>
-                                  </p:childTnLst>
-                                </p:cTn>
-                              </p:par>
-                            </p:childTnLst>
-                          </p:cTn>
-                        </p:par>
-                      </p:childTnLst>
-                    </p:cTn>
-                  </p:par>
-                </p:childTnLst>
-              </p:cTn>
-              <p:prevCondLst>
-                <p:cond evt="onPrev" delay="0">
-                  <p:tgtEl>
-                    <p:sldTgt/>
-                  </p:tgtEl>
-                </p:cond>
-              </p:prevCondLst>
-              <p:nextCondLst>
-                <p:cond evt="onNext" delay="0">
-                  <p:tgtEl>
-                    <p:sldTgt/>
-                  </p:tgtEl>
-                </p:cond>
-              </p:nextCondLst>
-            </p:seq>
-          </p:childTnLst>
-        </p:cTn>
-      </p:par>
-    </p:tnLst>
-    <p:bldLst>
-      <p:bldP spid="2" grpId="0"/>
-    </p:bldLst>
-  </p:timing>
 </p:sld>
 </file>
 
@@ -20692,8 +20605,8 @@
           <a:chExt cx="0" cy="0"/>
         </a:xfrm>
       </p:grpSpPr>
-      <mc:AlternateContent xmlns:mc="http://schemas.openxmlformats.org/markup-compatibility/2006">
-        <mc:Choice xmlns:a14="http://schemas.microsoft.com/office/drawing/2010/main" Requires="a14">
+      <mc:AlternateContent xmlns:mc="http://schemas.openxmlformats.org/markup-compatibility/2006" xmlns:a14="http://schemas.microsoft.com/office/drawing/2010/main">
+        <mc:Choice Requires="a14">
           <p:sp>
             <p:nvSpPr>
               <p:cNvPr id="18" name="TextBox 17">
@@ -20761,7 +20674,7 @@
             </p:txBody>
           </p:sp>
         </mc:Choice>
-        <mc:Fallback>
+        <mc:Fallback xmlns="">
           <p:sp>
             <p:nvSpPr>
               <p:cNvPr id="18" name="TextBox 17">
@@ -20806,8 +20719,8 @@
           </p:sp>
         </mc:Fallback>
       </mc:AlternateContent>
-      <mc:AlternateContent xmlns:mc="http://schemas.openxmlformats.org/markup-compatibility/2006">
-        <mc:Choice xmlns:a14="http://schemas.microsoft.com/office/drawing/2010/main" Requires="a14">
+      <mc:AlternateContent xmlns:mc="http://schemas.openxmlformats.org/markup-compatibility/2006" xmlns:a14="http://schemas.microsoft.com/office/drawing/2010/main">
+        <mc:Choice Requires="a14">
           <p:sp>
             <p:nvSpPr>
               <p:cNvPr id="5" name="TextBox 4">
@@ -20943,7 +20856,7 @@
             </p:txBody>
           </p:sp>
         </mc:Choice>
-        <mc:Fallback>
+        <mc:Fallback xmlns="">
           <p:sp>
             <p:nvSpPr>
               <p:cNvPr id="5" name="TextBox 4">
@@ -23341,8 +23254,8 @@
           <a:chExt cx="0" cy="0"/>
         </a:xfrm>
       </p:grpSpPr>
-      <mc:AlternateContent xmlns:mc="http://schemas.openxmlformats.org/markup-compatibility/2006">
-        <mc:Choice xmlns:a14="http://schemas.microsoft.com/office/drawing/2010/main" Requires="a14">
+      <mc:AlternateContent xmlns:mc="http://schemas.openxmlformats.org/markup-compatibility/2006" xmlns:a14="http://schemas.microsoft.com/office/drawing/2010/main">
+        <mc:Choice Requires="a14">
           <p:sp>
             <p:nvSpPr>
               <p:cNvPr id="3" name="TextBox 2">
@@ -23792,7 +23705,7 @@
             </p:txBody>
           </p:sp>
         </mc:Choice>
-        <mc:Fallback>
+        <mc:Fallback xmlns="">
           <p:sp>
             <p:nvSpPr>
               <p:cNvPr id="3" name="TextBox 2">
@@ -23837,8 +23750,8 @@
           </p:sp>
         </mc:Fallback>
       </mc:AlternateContent>
-      <mc:AlternateContent xmlns:mc="http://schemas.openxmlformats.org/markup-compatibility/2006">
-        <mc:Choice xmlns:a14="http://schemas.microsoft.com/office/drawing/2010/main" Requires="a14">
+      <mc:AlternateContent xmlns:mc="http://schemas.openxmlformats.org/markup-compatibility/2006" xmlns:a14="http://schemas.microsoft.com/office/drawing/2010/main">
+        <mc:Choice Requires="a14">
           <p:sp>
             <p:nvSpPr>
               <p:cNvPr id="5" name="TextBox 4">
@@ -24144,7 +24057,7 @@
             </p:txBody>
           </p:sp>
         </mc:Choice>
-        <mc:Fallback>
+        <mc:Fallback xmlns="">
           <p:sp>
             <p:nvSpPr>
               <p:cNvPr id="5" name="TextBox 4">
@@ -24189,8 +24102,8 @@
           </p:sp>
         </mc:Fallback>
       </mc:AlternateContent>
-      <mc:AlternateContent xmlns:mc="http://schemas.openxmlformats.org/markup-compatibility/2006">
-        <mc:Choice xmlns:a14="http://schemas.microsoft.com/office/drawing/2010/main" Requires="a14">
+      <mc:AlternateContent xmlns:mc="http://schemas.openxmlformats.org/markup-compatibility/2006" xmlns:a14="http://schemas.microsoft.com/office/drawing/2010/main">
+        <mc:Choice Requires="a14">
           <p:sp>
             <p:nvSpPr>
               <p:cNvPr id="17" name="TextBox 16">
@@ -24420,7 +24333,7 @@
             </p:txBody>
           </p:sp>
         </mc:Choice>
-        <mc:Fallback>
+        <mc:Fallback xmlns="">
           <p:sp>
             <p:nvSpPr>
               <p:cNvPr id="17" name="TextBox 16">
@@ -24465,8 +24378,8 @@
           </p:sp>
         </mc:Fallback>
       </mc:AlternateContent>
-      <mc:AlternateContent xmlns:mc="http://schemas.openxmlformats.org/markup-compatibility/2006">
-        <mc:Choice xmlns:a14="http://schemas.microsoft.com/office/drawing/2010/main" Requires="a14">
+      <mc:AlternateContent xmlns:mc="http://schemas.openxmlformats.org/markup-compatibility/2006" xmlns:a14="http://schemas.microsoft.com/office/drawing/2010/main">
+        <mc:Choice Requires="a14">
           <p:sp>
             <p:nvSpPr>
               <p:cNvPr id="20" name="TextBox 19">
@@ -24818,7 +24731,7 @@
             </p:txBody>
           </p:sp>
         </mc:Choice>
-        <mc:Fallback>
+        <mc:Fallback xmlns="">
           <p:sp>
             <p:nvSpPr>
               <p:cNvPr id="20" name="TextBox 19">
@@ -25031,8 +24944,8 @@
           </a:fontRef>
         </p:style>
       </p:cxnSp>
-      <mc:AlternateContent xmlns:mc="http://schemas.openxmlformats.org/markup-compatibility/2006">
-        <mc:Choice xmlns:a14="http://schemas.microsoft.com/office/drawing/2010/main" Requires="a14">
+      <mc:AlternateContent xmlns:mc="http://schemas.openxmlformats.org/markup-compatibility/2006" xmlns:a14="http://schemas.microsoft.com/office/drawing/2010/main">
+        <mc:Choice Requires="a14">
           <p:sp>
             <p:nvSpPr>
               <p:cNvPr id="22" name="TextBox 21">
@@ -25082,7 +24995,7 @@
             </p:txBody>
           </p:sp>
         </mc:Choice>
-        <mc:Fallback>
+        <mc:Fallback xmlns="">
           <p:sp>
             <p:nvSpPr>
               <p:cNvPr id="22" name="TextBox 21">
@@ -25127,8 +25040,8 @@
           </p:sp>
         </mc:Fallback>
       </mc:AlternateContent>
-      <mc:AlternateContent xmlns:mc="http://schemas.openxmlformats.org/markup-compatibility/2006">
-        <mc:Choice xmlns:a14="http://schemas.microsoft.com/office/drawing/2010/main" Requires="a14">
+      <mc:AlternateContent xmlns:mc="http://schemas.openxmlformats.org/markup-compatibility/2006" xmlns:a14="http://schemas.microsoft.com/office/drawing/2010/main">
+        <mc:Choice Requires="a14">
           <p:sp>
             <p:nvSpPr>
               <p:cNvPr id="23" name="TextBox 22">
@@ -25178,7 +25091,7 @@
             </p:txBody>
           </p:sp>
         </mc:Choice>
-        <mc:Fallback>
+        <mc:Fallback xmlns="">
           <p:sp>
             <p:nvSpPr>
               <p:cNvPr id="23" name="TextBox 22">
@@ -25223,8 +25136,8 @@
           </p:sp>
         </mc:Fallback>
       </mc:AlternateContent>
-      <mc:AlternateContent xmlns:mc="http://schemas.openxmlformats.org/markup-compatibility/2006">
-        <mc:Choice xmlns:a14="http://schemas.microsoft.com/office/drawing/2010/main" Requires="a14">
+      <mc:AlternateContent xmlns:mc="http://schemas.openxmlformats.org/markup-compatibility/2006" xmlns:a14="http://schemas.microsoft.com/office/drawing/2010/main">
+        <mc:Choice Requires="a14">
           <p:sp>
             <p:nvSpPr>
               <p:cNvPr id="24" name="TextBox 23">
@@ -25274,7 +25187,7 @@
             </p:txBody>
           </p:sp>
         </mc:Choice>
-        <mc:Fallback>
+        <mc:Fallback xmlns="">
           <p:sp>
             <p:nvSpPr>
               <p:cNvPr id="24" name="TextBox 23">
@@ -25409,8 +25322,8 @@
           </a:p>
         </p:txBody>
       </p:sp>
-      <mc:AlternateContent xmlns:mc="http://schemas.openxmlformats.org/markup-compatibility/2006">
-        <mc:Choice xmlns:a14="http://schemas.microsoft.com/office/drawing/2010/main" Requires="a14">
+      <mc:AlternateContent xmlns:mc="http://schemas.openxmlformats.org/markup-compatibility/2006" xmlns:a14="http://schemas.microsoft.com/office/drawing/2010/main">
+        <mc:Choice Requires="a14">
           <p:sp>
             <p:nvSpPr>
               <p:cNvPr id="29" name="TextBox 28">
@@ -25479,7 +25392,7 @@
             </p:txBody>
           </p:sp>
         </mc:Choice>
-        <mc:Fallback>
+        <mc:Fallback xmlns="">
           <p:sp>
             <p:nvSpPr>
               <p:cNvPr id="29" name="TextBox 28">
@@ -25524,8 +25437,8 @@
           </p:sp>
         </mc:Fallback>
       </mc:AlternateContent>
-      <mc:AlternateContent xmlns:mc="http://schemas.openxmlformats.org/markup-compatibility/2006">
-        <mc:Choice xmlns:a14="http://schemas.microsoft.com/office/drawing/2010/main" Requires="a14">
+      <mc:AlternateContent xmlns:mc="http://schemas.openxmlformats.org/markup-compatibility/2006" xmlns:a14="http://schemas.microsoft.com/office/drawing/2010/main">
+        <mc:Choice Requires="a14">
           <p:sp>
             <p:nvSpPr>
               <p:cNvPr id="30" name="TextBox 29">
@@ -25575,7 +25488,7 @@
             </p:txBody>
           </p:sp>
         </mc:Choice>
-        <mc:Fallback>
+        <mc:Fallback xmlns="">
           <p:sp>
             <p:nvSpPr>
               <p:cNvPr id="30" name="TextBox 29">
@@ -25620,8 +25533,8 @@
           </p:sp>
         </mc:Fallback>
       </mc:AlternateContent>
-      <mc:AlternateContent xmlns:mc="http://schemas.openxmlformats.org/markup-compatibility/2006">
-        <mc:Choice xmlns:a14="http://schemas.microsoft.com/office/drawing/2010/main" Requires="a14">
+      <mc:AlternateContent xmlns:mc="http://schemas.openxmlformats.org/markup-compatibility/2006" xmlns:a14="http://schemas.microsoft.com/office/drawing/2010/main">
+        <mc:Choice Requires="a14">
           <p:sp>
             <p:nvSpPr>
               <p:cNvPr id="32" name="TextBox 31">
@@ -25690,7 +25603,7 @@
             </p:txBody>
           </p:sp>
         </mc:Choice>
-        <mc:Fallback>
+        <mc:Fallback xmlns="">
           <p:sp>
             <p:nvSpPr>
               <p:cNvPr id="32" name="TextBox 31">
@@ -35907,8 +35820,8 @@
           </a:fontRef>
         </p:style>
       </p:cxnSp>
-      <mc:AlternateContent xmlns:mc="http://schemas.openxmlformats.org/markup-compatibility/2006">
-        <mc:Choice xmlns:a14="http://schemas.microsoft.com/office/drawing/2010/main" Requires="a14">
+      <mc:AlternateContent xmlns:mc="http://schemas.openxmlformats.org/markup-compatibility/2006" xmlns:a14="http://schemas.microsoft.com/office/drawing/2010/main">
+        <mc:Choice Requires="a14">
           <p:sp>
             <p:nvSpPr>
               <p:cNvPr id="74" name="TextBox 73">
@@ -35983,7 +35896,7 @@
             </p:txBody>
           </p:sp>
         </mc:Choice>
-        <mc:Fallback>
+        <mc:Fallback xmlns="">
           <p:sp>
             <p:nvSpPr>
               <p:cNvPr id="74" name="TextBox 73">
@@ -36253,8 +36166,8 @@
           </a:fontRef>
         </p:style>
       </p:cxnSp>
-      <mc:AlternateContent xmlns:mc="http://schemas.openxmlformats.org/markup-compatibility/2006">
-        <mc:Choice xmlns:a14="http://schemas.microsoft.com/office/drawing/2010/main" Requires="a14">
+      <mc:AlternateContent xmlns:mc="http://schemas.openxmlformats.org/markup-compatibility/2006" xmlns:a14="http://schemas.microsoft.com/office/drawing/2010/main">
+        <mc:Choice Requires="a14">
           <p:sp>
             <p:nvSpPr>
               <p:cNvPr id="88" name="TextBox 87">
@@ -36309,7 +36222,7 @@
             </p:txBody>
           </p:sp>
         </mc:Choice>
-        <mc:Fallback>
+        <mc:Fallback xmlns="">
           <p:sp>
             <p:nvSpPr>
               <p:cNvPr id="88" name="TextBox 87">
@@ -36354,8 +36267,8 @@
           </p:sp>
         </mc:Fallback>
       </mc:AlternateContent>
-      <mc:AlternateContent xmlns:mc="http://schemas.openxmlformats.org/markup-compatibility/2006">
-        <mc:Choice xmlns:a14="http://schemas.microsoft.com/office/drawing/2010/main" Requires="a14">
+      <mc:AlternateContent xmlns:mc="http://schemas.openxmlformats.org/markup-compatibility/2006" xmlns:a14="http://schemas.microsoft.com/office/drawing/2010/main">
+        <mc:Choice Requires="a14">
           <p:sp>
             <p:nvSpPr>
               <p:cNvPr id="12" name="TextBox 11">
@@ -36424,7 +36337,7 @@
             </p:txBody>
           </p:sp>
         </mc:Choice>
-        <mc:Fallback>
+        <mc:Fallback xmlns="">
           <p:sp>
             <p:nvSpPr>
               <p:cNvPr id="12" name="TextBox 11">
@@ -36469,8 +36382,8 @@
           </p:sp>
         </mc:Fallback>
       </mc:AlternateContent>
-      <mc:AlternateContent xmlns:mc="http://schemas.openxmlformats.org/markup-compatibility/2006">
-        <mc:Choice xmlns:a14="http://schemas.microsoft.com/office/drawing/2010/main" Requires="a14">
+      <mc:AlternateContent xmlns:mc="http://schemas.openxmlformats.org/markup-compatibility/2006" xmlns:a14="http://schemas.microsoft.com/office/drawing/2010/main">
+        <mc:Choice Requires="a14">
           <p:sp>
             <p:nvSpPr>
               <p:cNvPr id="4" name="TextBox 3">
@@ -36520,7 +36433,7 @@
             </p:txBody>
           </p:sp>
         </mc:Choice>
-        <mc:Fallback>
+        <mc:Fallback xmlns="">
           <p:sp>
             <p:nvSpPr>
               <p:cNvPr id="4" name="TextBox 3">
@@ -36565,8 +36478,8 @@
           </p:sp>
         </mc:Fallback>
       </mc:AlternateContent>
-      <mc:AlternateContent xmlns:mc="http://schemas.openxmlformats.org/markup-compatibility/2006">
-        <mc:Choice xmlns:a14="http://schemas.microsoft.com/office/drawing/2010/main" Requires="a14">
+      <mc:AlternateContent xmlns:mc="http://schemas.openxmlformats.org/markup-compatibility/2006" xmlns:a14="http://schemas.microsoft.com/office/drawing/2010/main">
+        <mc:Choice Requires="a14">
           <p:sp>
             <p:nvSpPr>
               <p:cNvPr id="5" name="TextBox 4">
@@ -36853,7 +36766,7 @@
             </p:txBody>
           </p:sp>
         </mc:Choice>
-        <mc:Fallback>
+        <mc:Fallback xmlns="">
           <p:sp>
             <p:nvSpPr>
               <p:cNvPr id="5" name="TextBox 4">
@@ -36898,8 +36811,8 @@
           </p:sp>
         </mc:Fallback>
       </mc:AlternateContent>
-      <mc:AlternateContent xmlns:mc="http://schemas.openxmlformats.org/markup-compatibility/2006">
-        <mc:Choice xmlns:a14="http://schemas.microsoft.com/office/drawing/2010/main" Requires="a14">
+      <mc:AlternateContent xmlns:mc="http://schemas.openxmlformats.org/markup-compatibility/2006" xmlns:a14="http://schemas.microsoft.com/office/drawing/2010/main">
+        <mc:Choice Requires="a14">
           <p:sp>
             <p:nvSpPr>
               <p:cNvPr id="8" name="TextBox 7">
@@ -36949,7 +36862,7 @@
             </p:txBody>
           </p:sp>
         </mc:Choice>
-        <mc:Fallback>
+        <mc:Fallback xmlns="">
           <p:sp>
             <p:nvSpPr>
               <p:cNvPr id="8" name="TextBox 7">
@@ -37004,168 +36917,6 @@
   <p:clrMapOvr>
     <a:masterClrMapping/>
   </p:clrMapOvr>
-  <p:timing>
-    <p:tnLst>
-      <p:par>
-        <p:cTn id="1" dur="indefinite" restart="never" nodeType="tmRoot">
-          <p:childTnLst>
-            <p:seq concurrent="1" nextAc="seek">
-              <p:cTn id="2" dur="indefinite" nodeType="mainSeq">
-                <p:childTnLst>
-                  <p:par>
-                    <p:cTn id="3" fill="hold">
-                      <p:stCondLst>
-                        <p:cond delay="indefinite"/>
-                      </p:stCondLst>
-                      <p:childTnLst>
-                        <p:par>
-                          <p:cTn id="4" fill="hold">
-                            <p:stCondLst>
-                              <p:cond delay="0"/>
-                            </p:stCondLst>
-                            <p:childTnLst>
-                              <p:par>
-                                <p:cTn id="5" presetID="1" presetClass="entr" presetSubtype="0" fill="hold" grpId="0" nodeType="clickEffect">
-                                  <p:stCondLst>
-                                    <p:cond delay="0"/>
-                                  </p:stCondLst>
-                                  <p:childTnLst>
-                                    <p:set>
-                                      <p:cBhvr>
-                                        <p:cTn id="6" dur="1" fill="hold">
-                                          <p:stCondLst>
-                                            <p:cond delay="0"/>
-                                          </p:stCondLst>
-                                        </p:cTn>
-                                        <p:tgtEl>
-                                          <p:spTgt spid="77"/>
-                                        </p:tgtEl>
-                                        <p:attrNameLst>
-                                          <p:attrName>style.visibility</p:attrName>
-                                        </p:attrNameLst>
-                                      </p:cBhvr>
-                                      <p:to>
-                                        <p:strVal val="visible"/>
-                                      </p:to>
-                                    </p:set>
-                                  </p:childTnLst>
-                                </p:cTn>
-                              </p:par>
-                              <p:par>
-                                <p:cTn id="7" presetID="1" presetClass="entr" presetSubtype="0" fill="hold" grpId="0" nodeType="withEffect">
-                                  <p:stCondLst>
-                                    <p:cond delay="0"/>
-                                  </p:stCondLst>
-                                  <p:childTnLst>
-                                    <p:set>
-                                      <p:cBhvr>
-                                        <p:cTn id="8" dur="1" fill="hold">
-                                          <p:stCondLst>
-                                            <p:cond delay="0"/>
-                                          </p:stCondLst>
-                                        </p:cTn>
-                                        <p:tgtEl>
-                                          <p:spTgt spid="74"/>
-                                        </p:tgtEl>
-                                        <p:attrNameLst>
-                                          <p:attrName>style.visibility</p:attrName>
-                                        </p:attrNameLst>
-                                      </p:cBhvr>
-                                      <p:to>
-                                        <p:strVal val="visible"/>
-                                      </p:to>
-                                    </p:set>
-                                  </p:childTnLst>
-                                </p:cTn>
-                              </p:par>
-                              <p:par>
-                                <p:cTn id="9" presetID="1" presetClass="entr" presetSubtype="0" fill="hold" grpId="0" nodeType="withEffect">
-                                  <p:stCondLst>
-                                    <p:cond delay="0"/>
-                                  </p:stCondLst>
-                                  <p:childTnLst>
-                                    <p:set>
-                                      <p:cBhvr>
-                                        <p:cTn id="10" dur="1" fill="hold">
-                                          <p:stCondLst>
-                                            <p:cond delay="0"/>
-                                          </p:stCondLst>
-                                        </p:cTn>
-                                        <p:tgtEl>
-                                          <p:spTgt spid="68"/>
-                                        </p:tgtEl>
-                                        <p:attrNameLst>
-                                          <p:attrName>style.visibility</p:attrName>
-                                        </p:attrNameLst>
-                                      </p:cBhvr>
-                                      <p:to>
-                                        <p:strVal val="visible"/>
-                                      </p:to>
-                                    </p:set>
-                                  </p:childTnLst>
-                                </p:cTn>
-                              </p:par>
-                              <p:par>
-                                <p:cTn id="11" presetID="1" presetClass="entr" presetSubtype="0" fill="hold" grpId="0" nodeType="withEffect">
-                                  <p:stCondLst>
-                                    <p:cond delay="0"/>
-                                  </p:stCondLst>
-                                  <p:childTnLst>
-                                    <p:set>
-                                      <p:cBhvr>
-                                        <p:cTn id="12" dur="1" fill="hold">
-                                          <p:stCondLst>
-                                            <p:cond delay="0"/>
-                                          </p:stCondLst>
-                                        </p:cTn>
-                                        <p:tgtEl>
-                                          <p:spTgt spid="12"/>
-                                        </p:tgtEl>
-                                        <p:attrNameLst>
-                                          <p:attrName>style.visibility</p:attrName>
-                                        </p:attrNameLst>
-                                      </p:cBhvr>
-                                      <p:to>
-                                        <p:strVal val="visible"/>
-                                      </p:to>
-                                    </p:set>
-                                  </p:childTnLst>
-                                </p:cTn>
-                              </p:par>
-                            </p:childTnLst>
-                          </p:cTn>
-                        </p:par>
-                      </p:childTnLst>
-                    </p:cTn>
-                  </p:par>
-                </p:childTnLst>
-              </p:cTn>
-              <p:prevCondLst>
-                <p:cond evt="onPrev" delay="0">
-                  <p:tgtEl>
-                    <p:sldTgt/>
-                  </p:tgtEl>
-                </p:cond>
-              </p:prevCondLst>
-              <p:nextCondLst>
-                <p:cond evt="onNext" delay="0">
-                  <p:tgtEl>
-                    <p:sldTgt/>
-                  </p:tgtEl>
-                </p:cond>
-              </p:nextCondLst>
-            </p:seq>
-          </p:childTnLst>
-        </p:cTn>
-      </p:par>
-    </p:tnLst>
-    <p:bldLst>
-      <p:bldP spid="68" grpId="0"/>
-      <p:bldP spid="74" grpId="0"/>
-      <p:bldP spid="77" grpId="0" animBg="1"/>
-      <p:bldP spid="12" grpId="0"/>
-    </p:bldLst>
-  </p:timing>
 </p:sld>
 </file>
 
@@ -37644,8 +37395,8 @@
           </p:txBody>
         </p:sp>
       </p:grpSp>
-      <mc:AlternateContent xmlns:mc="http://schemas.openxmlformats.org/markup-compatibility/2006">
-        <mc:Choice xmlns:a14="http://schemas.microsoft.com/office/drawing/2010/main" Requires="a14">
+      <mc:AlternateContent xmlns:mc="http://schemas.openxmlformats.org/markup-compatibility/2006" xmlns:a14="http://schemas.microsoft.com/office/drawing/2010/main">
+        <mc:Choice Requires="a14">
           <p:sp>
             <p:nvSpPr>
               <p:cNvPr id="68" name="TextBox 67">
@@ -37695,7 +37446,7 @@
             </p:txBody>
           </p:sp>
         </mc:Choice>
-        <mc:Fallback>
+        <mc:Fallback xmlns="">
           <p:sp>
             <p:nvSpPr>
               <p:cNvPr id="68" name="TextBox 67">
@@ -37776,8 +37527,8 @@
           </a:fontRef>
         </p:style>
       </p:cxnSp>
-      <mc:AlternateContent xmlns:mc="http://schemas.openxmlformats.org/markup-compatibility/2006">
-        <mc:Choice xmlns:a14="http://schemas.microsoft.com/office/drawing/2010/main" Requires="a14">
+      <mc:AlternateContent xmlns:mc="http://schemas.openxmlformats.org/markup-compatibility/2006" xmlns:a14="http://schemas.microsoft.com/office/drawing/2010/main">
+        <mc:Choice Requires="a14">
           <p:sp>
             <p:nvSpPr>
               <p:cNvPr id="74" name="TextBox 73">
@@ -37852,7 +37603,7 @@
             </p:txBody>
           </p:sp>
         </mc:Choice>
-        <mc:Fallback>
+        <mc:Fallback xmlns="">
           <p:sp>
             <p:nvSpPr>
               <p:cNvPr id="74" name="TextBox 73">
@@ -37897,8 +37648,8 @@
           </p:sp>
         </mc:Fallback>
       </mc:AlternateContent>
-      <mc:AlternateContent xmlns:mc="http://schemas.openxmlformats.org/markup-compatibility/2006">
-        <mc:Choice xmlns:a14="http://schemas.microsoft.com/office/drawing/2010/main" Requires="a14">
+      <mc:AlternateContent xmlns:mc="http://schemas.openxmlformats.org/markup-compatibility/2006" xmlns:a14="http://schemas.microsoft.com/office/drawing/2010/main">
+        <mc:Choice Requires="a14">
           <p:sp>
             <p:nvSpPr>
               <p:cNvPr id="80" name="TextBox 79">
@@ -37948,7 +37699,7 @@
             </p:txBody>
           </p:sp>
         </mc:Choice>
-        <mc:Fallback>
+        <mc:Fallback xmlns="">
           <p:sp>
             <p:nvSpPr>
               <p:cNvPr id="80" name="TextBox 79">
@@ -38125,8 +37876,8 @@
           </a:fontRef>
         </p:style>
       </p:cxnSp>
-      <mc:AlternateContent xmlns:mc="http://schemas.openxmlformats.org/markup-compatibility/2006">
-        <mc:Choice xmlns:a14="http://schemas.microsoft.com/office/drawing/2010/main" Requires="a14">
+      <mc:AlternateContent xmlns:mc="http://schemas.openxmlformats.org/markup-compatibility/2006" xmlns:a14="http://schemas.microsoft.com/office/drawing/2010/main">
+        <mc:Choice Requires="a14">
           <p:sp>
             <p:nvSpPr>
               <p:cNvPr id="8" name="TextBox 7">
@@ -38176,7 +37927,7 @@
             </p:txBody>
           </p:sp>
         </mc:Choice>
-        <mc:Fallback>
+        <mc:Fallback xmlns="">
           <p:sp>
             <p:nvSpPr>
               <p:cNvPr id="8" name="TextBox 7">
@@ -38221,8 +37972,8 @@
           </p:sp>
         </mc:Fallback>
       </mc:AlternateContent>
-      <mc:AlternateContent xmlns:mc="http://schemas.openxmlformats.org/markup-compatibility/2006">
-        <mc:Choice xmlns:a14="http://schemas.microsoft.com/office/drawing/2010/main" Requires="a14">
+      <mc:AlternateContent xmlns:mc="http://schemas.openxmlformats.org/markup-compatibility/2006" xmlns:a14="http://schemas.microsoft.com/office/drawing/2010/main">
+        <mc:Choice Requires="a14">
           <p:sp>
             <p:nvSpPr>
               <p:cNvPr id="9" name="TextBox 8">
@@ -38251,7 +38002,6 @@
               </a:bodyPr>
               <a:lstStyle/>
               <a:p>
-                <a:pPr/>
                 <a14:m>
                   <m:oMath xmlns:m="http://schemas.openxmlformats.org/officeDocument/2006/math">
                     <m:f>
@@ -38289,7 +38039,7 @@
             </p:txBody>
           </p:sp>
         </mc:Choice>
-        <mc:Fallback>
+        <mc:Fallback xmlns="">
           <p:sp>
             <p:nvSpPr>
               <p:cNvPr id="9" name="TextBox 8">
@@ -38381,8 +38131,8 @@
           </a:p>
         </p:txBody>
       </p:sp>
-      <mc:AlternateContent xmlns:mc="http://schemas.openxmlformats.org/markup-compatibility/2006">
-        <mc:Choice xmlns:a14="http://schemas.microsoft.com/office/drawing/2010/main" Requires="a14">
+      <mc:AlternateContent xmlns:mc="http://schemas.openxmlformats.org/markup-compatibility/2006" xmlns:a14="http://schemas.microsoft.com/office/drawing/2010/main">
+        <mc:Choice Requires="a14">
           <p:sp>
             <p:nvSpPr>
               <p:cNvPr id="13" name="TextBox 12">
@@ -38451,7 +38201,7 @@
             </p:txBody>
           </p:sp>
         </mc:Choice>
-        <mc:Fallback>
+        <mc:Fallback xmlns="">
           <p:sp>
             <p:nvSpPr>
               <p:cNvPr id="13" name="TextBox 12">
@@ -38496,8 +38246,8 @@
           </p:sp>
         </mc:Fallback>
       </mc:AlternateContent>
-      <mc:AlternateContent xmlns:mc="http://schemas.openxmlformats.org/markup-compatibility/2006">
-        <mc:Choice xmlns:a14="http://schemas.microsoft.com/office/drawing/2010/main" Requires="a14">
+      <mc:AlternateContent xmlns:mc="http://schemas.openxmlformats.org/markup-compatibility/2006" xmlns:a14="http://schemas.microsoft.com/office/drawing/2010/main">
+        <mc:Choice Requires="a14">
           <p:sp>
             <p:nvSpPr>
               <p:cNvPr id="14" name="TextBox 13">
@@ -38547,7 +38297,7 @@
             </p:txBody>
           </p:sp>
         </mc:Choice>
-        <mc:Fallback>
+        <mc:Fallback xmlns="">
           <p:sp>
             <p:nvSpPr>
               <p:cNvPr id="14" name="TextBox 13">
@@ -38612,8 +38362,8 @@
             <a:chExt cx="5135508" cy="3244963"/>
           </a:xfrm>
         </p:grpSpPr>
-        <mc:AlternateContent xmlns:mc="http://schemas.openxmlformats.org/markup-compatibility/2006">
-          <mc:Choice xmlns:a14="http://schemas.microsoft.com/office/drawing/2010/main" Requires="a14">
+        <mc:AlternateContent xmlns:mc="http://schemas.openxmlformats.org/markup-compatibility/2006" xmlns:a14="http://schemas.microsoft.com/office/drawing/2010/main">
+          <mc:Choice Requires="a14">
             <p:sp>
               <p:nvSpPr>
                 <p:cNvPr id="15" name="TextBox 14">
@@ -38642,6 +38392,7 @@
                 </a:bodyPr>
                 <a:lstStyle/>
                 <a:p>
+                  <a:pPr/>
                   <a14:m>
                     <m:oMathPara xmlns:m="http://schemas.openxmlformats.org/officeDocument/2006/math">
                       <m:oMathParaPr>
@@ -38733,7 +38484,7 @@
               </p:txBody>
             </p:sp>
           </mc:Choice>
-          <mc:Fallback>
+          <mc:Fallback xmlns="">
             <p:sp>
               <p:nvSpPr>
                 <p:cNvPr id="15" name="TextBox 14">
@@ -38778,8 +38529,8 @@
             </p:sp>
           </mc:Fallback>
         </mc:AlternateContent>
-        <mc:AlternateContent xmlns:mc="http://schemas.openxmlformats.org/markup-compatibility/2006">
-          <mc:Choice xmlns:a14="http://schemas.microsoft.com/office/drawing/2010/main" Requires="a14">
+        <mc:AlternateContent xmlns:mc="http://schemas.openxmlformats.org/markup-compatibility/2006" xmlns:a14="http://schemas.microsoft.com/office/drawing/2010/main">
+          <mc:Choice Requires="a14">
             <p:sp>
               <p:nvSpPr>
                 <p:cNvPr id="16" name="TextBox 15">
@@ -38904,7 +38655,7 @@
               </p:txBody>
             </p:sp>
           </mc:Choice>
-          <mc:Fallback>
+          <mc:Fallback xmlns="">
             <p:sp>
               <p:nvSpPr>
                 <p:cNvPr id="16" name="TextBox 15">
@@ -38949,8 +38700,8 @@
             </p:sp>
           </mc:Fallback>
         </mc:AlternateContent>
-        <mc:AlternateContent xmlns:mc="http://schemas.openxmlformats.org/markup-compatibility/2006">
-          <mc:Choice xmlns:a14="http://schemas.microsoft.com/office/drawing/2010/main" Requires="a14">
+        <mc:AlternateContent xmlns:mc="http://schemas.openxmlformats.org/markup-compatibility/2006" xmlns:a14="http://schemas.microsoft.com/office/drawing/2010/main">
+          <mc:Choice Requires="a14">
             <p:sp>
               <p:nvSpPr>
                 <p:cNvPr id="17" name="TextBox 16">
@@ -39120,7 +38871,7 @@
               </p:txBody>
             </p:sp>
           </mc:Choice>
-          <mc:Fallback>
+          <mc:Fallback xmlns="">
             <p:sp>
               <p:nvSpPr>
                 <p:cNvPr id="17" name="TextBox 16">
@@ -39165,8 +38916,8 @@
             </p:sp>
           </mc:Fallback>
         </mc:AlternateContent>
-        <mc:AlternateContent xmlns:mc="http://schemas.openxmlformats.org/markup-compatibility/2006">
-          <mc:Choice xmlns:a14="http://schemas.microsoft.com/office/drawing/2010/main" Requires="a14">
+        <mc:AlternateContent xmlns:mc="http://schemas.openxmlformats.org/markup-compatibility/2006" xmlns:a14="http://schemas.microsoft.com/office/drawing/2010/main">
+          <mc:Choice Requires="a14">
             <p:sp>
               <p:nvSpPr>
                 <p:cNvPr id="18" name="TextBox 17">
@@ -39451,7 +39202,7 @@
               </p:txBody>
             </p:sp>
           </mc:Choice>
-          <mc:Fallback>
+          <mc:Fallback xmlns="">
             <p:sp>
               <p:nvSpPr>
                 <p:cNvPr id="18" name="TextBox 17">
@@ -39496,8 +39247,8 @@
             </p:sp>
           </mc:Fallback>
         </mc:AlternateContent>
-        <mc:AlternateContent xmlns:mc="http://schemas.openxmlformats.org/markup-compatibility/2006">
-          <mc:Choice xmlns:a14="http://schemas.microsoft.com/office/drawing/2010/main" Requires="a14">
+        <mc:AlternateContent xmlns:mc="http://schemas.openxmlformats.org/markup-compatibility/2006" xmlns:a14="http://schemas.microsoft.com/office/drawing/2010/main">
+          <mc:Choice Requires="a14">
             <p:sp>
               <p:nvSpPr>
                 <p:cNvPr id="21" name="TextBox 20">
@@ -39526,7 +39277,6 @@
                 </a:bodyPr>
                 <a:lstStyle/>
                 <a:p>
-                  <a:pPr/>
                   <a14:m>
                     <m:oMath xmlns:m="http://schemas.openxmlformats.org/officeDocument/2006/math">
                       <m:r>
@@ -39723,7 +39473,7 @@
               </p:txBody>
             </p:sp>
           </mc:Choice>
-          <mc:Fallback>
+          <mc:Fallback xmlns="">
             <p:sp>
               <p:nvSpPr>
                 <p:cNvPr id="21" name="TextBox 20">
@@ -39823,168 +39573,6 @@
   <p:clrMapOvr>
     <a:masterClrMapping/>
   </p:clrMapOvr>
-  <p:timing>
-    <p:tnLst>
-      <p:par>
-        <p:cTn id="1" dur="indefinite" restart="never" nodeType="tmRoot">
-          <p:childTnLst>
-            <p:seq concurrent="1" nextAc="seek">
-              <p:cTn id="2" dur="indefinite" nodeType="mainSeq">
-                <p:childTnLst>
-                  <p:par>
-                    <p:cTn id="3" fill="hold">
-                      <p:stCondLst>
-                        <p:cond delay="indefinite"/>
-                      </p:stCondLst>
-                      <p:childTnLst>
-                        <p:par>
-                          <p:cTn id="4" fill="hold">
-                            <p:stCondLst>
-                              <p:cond delay="0"/>
-                            </p:stCondLst>
-                            <p:childTnLst>
-                              <p:par>
-                                <p:cTn id="5" presetID="1" presetClass="entr" presetSubtype="0" fill="hold" grpId="0" nodeType="clickEffect">
-                                  <p:stCondLst>
-                                    <p:cond delay="0"/>
-                                  </p:stCondLst>
-                                  <p:childTnLst>
-                                    <p:set>
-                                      <p:cBhvr>
-                                        <p:cTn id="6" dur="1" fill="hold">
-                                          <p:stCondLst>
-                                            <p:cond delay="0"/>
-                                          </p:stCondLst>
-                                        </p:cTn>
-                                        <p:tgtEl>
-                                          <p:spTgt spid="77"/>
-                                        </p:tgtEl>
-                                        <p:attrNameLst>
-                                          <p:attrName>style.visibility</p:attrName>
-                                        </p:attrNameLst>
-                                      </p:cBhvr>
-                                      <p:to>
-                                        <p:strVal val="visible"/>
-                                      </p:to>
-                                    </p:set>
-                                  </p:childTnLst>
-                                </p:cTn>
-                              </p:par>
-                              <p:par>
-                                <p:cTn id="7" presetID="1" presetClass="entr" presetSubtype="0" fill="hold" grpId="0" nodeType="withEffect">
-                                  <p:stCondLst>
-                                    <p:cond delay="0"/>
-                                  </p:stCondLst>
-                                  <p:childTnLst>
-                                    <p:set>
-                                      <p:cBhvr>
-                                        <p:cTn id="8" dur="1" fill="hold">
-                                          <p:stCondLst>
-                                            <p:cond delay="0"/>
-                                          </p:stCondLst>
-                                        </p:cTn>
-                                        <p:tgtEl>
-                                          <p:spTgt spid="74"/>
-                                        </p:tgtEl>
-                                        <p:attrNameLst>
-                                          <p:attrName>style.visibility</p:attrName>
-                                        </p:attrNameLst>
-                                      </p:cBhvr>
-                                      <p:to>
-                                        <p:strVal val="visible"/>
-                                      </p:to>
-                                    </p:set>
-                                  </p:childTnLst>
-                                </p:cTn>
-                              </p:par>
-                              <p:par>
-                                <p:cTn id="9" presetID="1" presetClass="entr" presetSubtype="0" fill="hold" grpId="0" nodeType="withEffect">
-                                  <p:stCondLst>
-                                    <p:cond delay="0"/>
-                                  </p:stCondLst>
-                                  <p:childTnLst>
-                                    <p:set>
-                                      <p:cBhvr>
-                                        <p:cTn id="10" dur="1" fill="hold">
-                                          <p:stCondLst>
-                                            <p:cond delay="0"/>
-                                          </p:stCondLst>
-                                        </p:cTn>
-                                        <p:tgtEl>
-                                          <p:spTgt spid="68"/>
-                                        </p:tgtEl>
-                                        <p:attrNameLst>
-                                          <p:attrName>style.visibility</p:attrName>
-                                        </p:attrNameLst>
-                                      </p:cBhvr>
-                                      <p:to>
-                                        <p:strVal val="visible"/>
-                                      </p:to>
-                                    </p:set>
-                                  </p:childTnLst>
-                                </p:cTn>
-                              </p:par>
-                              <p:par>
-                                <p:cTn id="11" presetID="1" presetClass="entr" presetSubtype="0" fill="hold" grpId="0" nodeType="withEffect">
-                                  <p:stCondLst>
-                                    <p:cond delay="0"/>
-                                  </p:stCondLst>
-                                  <p:childTnLst>
-                                    <p:set>
-                                      <p:cBhvr>
-                                        <p:cTn id="12" dur="1" fill="hold">
-                                          <p:stCondLst>
-                                            <p:cond delay="0"/>
-                                          </p:stCondLst>
-                                        </p:cTn>
-                                        <p:tgtEl>
-                                          <p:spTgt spid="13"/>
-                                        </p:tgtEl>
-                                        <p:attrNameLst>
-                                          <p:attrName>style.visibility</p:attrName>
-                                        </p:attrNameLst>
-                                      </p:cBhvr>
-                                      <p:to>
-                                        <p:strVal val="visible"/>
-                                      </p:to>
-                                    </p:set>
-                                  </p:childTnLst>
-                                </p:cTn>
-                              </p:par>
-                            </p:childTnLst>
-                          </p:cTn>
-                        </p:par>
-                      </p:childTnLst>
-                    </p:cTn>
-                  </p:par>
-                </p:childTnLst>
-              </p:cTn>
-              <p:prevCondLst>
-                <p:cond evt="onPrev" delay="0">
-                  <p:tgtEl>
-                    <p:sldTgt/>
-                  </p:tgtEl>
-                </p:cond>
-              </p:prevCondLst>
-              <p:nextCondLst>
-                <p:cond evt="onNext" delay="0">
-                  <p:tgtEl>
-                    <p:sldTgt/>
-                  </p:tgtEl>
-                </p:cond>
-              </p:nextCondLst>
-            </p:seq>
-          </p:childTnLst>
-        </p:cTn>
-      </p:par>
-    </p:tnLst>
-    <p:bldLst>
-      <p:bldP spid="68" grpId="0"/>
-      <p:bldP spid="74" grpId="0"/>
-      <p:bldP spid="77" grpId="0" animBg="1"/>
-      <p:bldP spid="13" grpId="0"/>
-    </p:bldLst>
-  </p:timing>
 </p:sld>
 </file>
 
@@ -40463,8 +40051,8 @@
           </p:txBody>
         </p:sp>
       </p:grpSp>
-      <mc:AlternateContent xmlns:mc="http://schemas.openxmlformats.org/markup-compatibility/2006">
-        <mc:Choice xmlns:a14="http://schemas.microsoft.com/office/drawing/2010/main" Requires="a14">
+      <mc:AlternateContent xmlns:mc="http://schemas.openxmlformats.org/markup-compatibility/2006" xmlns:a14="http://schemas.microsoft.com/office/drawing/2010/main">
+        <mc:Choice Requires="a14">
           <p:sp>
             <p:nvSpPr>
               <p:cNvPr id="68" name="TextBox 67">
@@ -40514,7 +40102,7 @@
             </p:txBody>
           </p:sp>
         </mc:Choice>
-        <mc:Fallback>
+        <mc:Fallback xmlns="">
           <p:sp>
             <p:nvSpPr>
               <p:cNvPr id="68" name="TextBox 67">
@@ -40595,8 +40183,8 @@
           </a:fontRef>
         </p:style>
       </p:cxnSp>
-      <mc:AlternateContent xmlns:mc="http://schemas.openxmlformats.org/markup-compatibility/2006">
-        <mc:Choice xmlns:a14="http://schemas.microsoft.com/office/drawing/2010/main" Requires="a14">
+      <mc:AlternateContent xmlns:mc="http://schemas.openxmlformats.org/markup-compatibility/2006" xmlns:a14="http://schemas.microsoft.com/office/drawing/2010/main">
+        <mc:Choice Requires="a14">
           <p:sp>
             <p:nvSpPr>
               <p:cNvPr id="74" name="TextBox 73">
@@ -40671,7 +40259,7 @@
             </p:txBody>
           </p:sp>
         </mc:Choice>
-        <mc:Fallback>
+        <mc:Fallback xmlns="">
           <p:sp>
             <p:nvSpPr>
               <p:cNvPr id="74" name="TextBox 73">
@@ -40716,8 +40304,8 @@
           </p:sp>
         </mc:Fallback>
       </mc:AlternateContent>
-      <mc:AlternateContent xmlns:mc="http://schemas.openxmlformats.org/markup-compatibility/2006">
-        <mc:Choice xmlns:a14="http://schemas.microsoft.com/office/drawing/2010/main" Requires="a14">
+      <mc:AlternateContent xmlns:mc="http://schemas.openxmlformats.org/markup-compatibility/2006" xmlns:a14="http://schemas.microsoft.com/office/drawing/2010/main">
+        <mc:Choice Requires="a14">
           <p:sp>
             <p:nvSpPr>
               <p:cNvPr id="80" name="TextBox 79">
@@ -40767,7 +40355,7 @@
             </p:txBody>
           </p:sp>
         </mc:Choice>
-        <mc:Fallback>
+        <mc:Fallback xmlns="">
           <p:sp>
             <p:nvSpPr>
               <p:cNvPr id="80" name="TextBox 79">
@@ -40944,8 +40532,8 @@
           </a:fontRef>
         </p:style>
       </p:cxnSp>
-      <mc:AlternateContent xmlns:mc="http://schemas.openxmlformats.org/markup-compatibility/2006">
-        <mc:Choice xmlns:a14="http://schemas.microsoft.com/office/drawing/2010/main" Requires="a14">
+      <mc:AlternateContent xmlns:mc="http://schemas.openxmlformats.org/markup-compatibility/2006" xmlns:a14="http://schemas.microsoft.com/office/drawing/2010/main">
+        <mc:Choice Requires="a14">
           <p:sp>
             <p:nvSpPr>
               <p:cNvPr id="8" name="TextBox 7">
@@ -40995,7 +40583,7 @@
             </p:txBody>
           </p:sp>
         </mc:Choice>
-        <mc:Fallback>
+        <mc:Fallback xmlns="">
           <p:sp>
             <p:nvSpPr>
               <p:cNvPr id="8" name="TextBox 7">
@@ -41040,8 +40628,8 @@
           </p:sp>
         </mc:Fallback>
       </mc:AlternateContent>
-      <mc:AlternateContent xmlns:mc="http://schemas.openxmlformats.org/markup-compatibility/2006">
-        <mc:Choice xmlns:a14="http://schemas.microsoft.com/office/drawing/2010/main" Requires="a14">
+      <mc:AlternateContent xmlns:mc="http://schemas.openxmlformats.org/markup-compatibility/2006" xmlns:a14="http://schemas.microsoft.com/office/drawing/2010/main">
+        <mc:Choice Requires="a14">
           <p:sp>
             <p:nvSpPr>
               <p:cNvPr id="9" name="TextBox 8">
@@ -41070,7 +40658,6 @@
               </a:bodyPr>
               <a:lstStyle/>
               <a:p>
-                <a:pPr/>
                 <a14:m>
                   <m:oMath xmlns:m="http://schemas.openxmlformats.org/officeDocument/2006/math">
                     <m:f>
@@ -41108,7 +40695,7 @@
             </p:txBody>
           </p:sp>
         </mc:Choice>
-        <mc:Fallback>
+        <mc:Fallback xmlns="">
           <p:sp>
             <p:nvSpPr>
               <p:cNvPr id="9" name="TextBox 8">
@@ -41200,8 +40787,8 @@
           </a:p>
         </p:txBody>
       </p:sp>
-      <mc:AlternateContent xmlns:mc="http://schemas.openxmlformats.org/markup-compatibility/2006">
-        <mc:Choice xmlns:a14="http://schemas.microsoft.com/office/drawing/2010/main" Requires="a14">
+      <mc:AlternateContent xmlns:mc="http://schemas.openxmlformats.org/markup-compatibility/2006" xmlns:a14="http://schemas.microsoft.com/office/drawing/2010/main">
+        <mc:Choice Requires="a14">
           <p:sp>
             <p:nvSpPr>
               <p:cNvPr id="13" name="TextBox 12">
@@ -41270,7 +40857,7 @@
             </p:txBody>
           </p:sp>
         </mc:Choice>
-        <mc:Fallback>
+        <mc:Fallback xmlns="">
           <p:sp>
             <p:nvSpPr>
               <p:cNvPr id="13" name="TextBox 12">
@@ -41315,8 +40902,8 @@
           </p:sp>
         </mc:Fallback>
       </mc:AlternateContent>
-      <mc:AlternateContent xmlns:mc="http://schemas.openxmlformats.org/markup-compatibility/2006">
-        <mc:Choice xmlns:a14="http://schemas.microsoft.com/office/drawing/2010/main" Requires="a14">
+      <mc:AlternateContent xmlns:mc="http://schemas.openxmlformats.org/markup-compatibility/2006" xmlns:a14="http://schemas.microsoft.com/office/drawing/2010/main">
+        <mc:Choice Requires="a14">
           <p:sp>
             <p:nvSpPr>
               <p:cNvPr id="14" name="TextBox 13">
@@ -41366,7 +40953,7 @@
             </p:txBody>
           </p:sp>
         </mc:Choice>
-        <mc:Fallback>
+        <mc:Fallback xmlns="">
           <p:sp>
             <p:nvSpPr>
               <p:cNvPr id="14" name="TextBox 13">
@@ -41411,8 +40998,8 @@
           </p:sp>
         </mc:Fallback>
       </mc:AlternateContent>
-      <mc:AlternateContent xmlns:mc="http://schemas.openxmlformats.org/markup-compatibility/2006">
-        <mc:Choice xmlns:a14="http://schemas.microsoft.com/office/drawing/2010/main" Requires="a14">
+      <mc:AlternateContent xmlns:mc="http://schemas.openxmlformats.org/markup-compatibility/2006" xmlns:a14="http://schemas.microsoft.com/office/drawing/2010/main">
+        <mc:Choice Requires="a14">
           <p:sp>
             <p:nvSpPr>
               <p:cNvPr id="21" name="TextBox 20">
@@ -41441,7 +41028,6 @@
               </a:bodyPr>
               <a:lstStyle/>
               <a:p>
-                <a:pPr/>
                 <a14:m>
                   <m:oMath xmlns:m="http://schemas.openxmlformats.org/officeDocument/2006/math">
                     <m:r>
@@ -41616,7 +41202,7 @@
             </p:txBody>
           </p:sp>
         </mc:Choice>
-        <mc:Fallback>
+        <mc:Fallback xmlns="">
           <p:sp>
             <p:nvSpPr>
               <p:cNvPr id="21" name="TextBox 20">
@@ -41753,168 +41339,6 @@
   <p:clrMapOvr>
     <a:masterClrMapping/>
   </p:clrMapOvr>
-  <p:timing>
-    <p:tnLst>
-      <p:par>
-        <p:cTn id="1" dur="indefinite" restart="never" nodeType="tmRoot">
-          <p:childTnLst>
-            <p:seq concurrent="1" nextAc="seek">
-              <p:cTn id="2" dur="indefinite" nodeType="mainSeq">
-                <p:childTnLst>
-                  <p:par>
-                    <p:cTn id="3" fill="hold">
-                      <p:stCondLst>
-                        <p:cond delay="indefinite"/>
-                      </p:stCondLst>
-                      <p:childTnLst>
-                        <p:par>
-                          <p:cTn id="4" fill="hold">
-                            <p:stCondLst>
-                              <p:cond delay="0"/>
-                            </p:stCondLst>
-                            <p:childTnLst>
-                              <p:par>
-                                <p:cTn id="5" presetID="1" presetClass="entr" presetSubtype="0" fill="hold" grpId="0" nodeType="clickEffect">
-                                  <p:stCondLst>
-                                    <p:cond delay="0"/>
-                                  </p:stCondLst>
-                                  <p:childTnLst>
-                                    <p:set>
-                                      <p:cBhvr>
-                                        <p:cTn id="6" dur="1" fill="hold">
-                                          <p:stCondLst>
-                                            <p:cond delay="0"/>
-                                          </p:stCondLst>
-                                        </p:cTn>
-                                        <p:tgtEl>
-                                          <p:spTgt spid="77"/>
-                                        </p:tgtEl>
-                                        <p:attrNameLst>
-                                          <p:attrName>style.visibility</p:attrName>
-                                        </p:attrNameLst>
-                                      </p:cBhvr>
-                                      <p:to>
-                                        <p:strVal val="visible"/>
-                                      </p:to>
-                                    </p:set>
-                                  </p:childTnLst>
-                                </p:cTn>
-                              </p:par>
-                              <p:par>
-                                <p:cTn id="7" presetID="1" presetClass="entr" presetSubtype="0" fill="hold" grpId="0" nodeType="withEffect">
-                                  <p:stCondLst>
-                                    <p:cond delay="0"/>
-                                  </p:stCondLst>
-                                  <p:childTnLst>
-                                    <p:set>
-                                      <p:cBhvr>
-                                        <p:cTn id="8" dur="1" fill="hold">
-                                          <p:stCondLst>
-                                            <p:cond delay="0"/>
-                                          </p:stCondLst>
-                                        </p:cTn>
-                                        <p:tgtEl>
-                                          <p:spTgt spid="74"/>
-                                        </p:tgtEl>
-                                        <p:attrNameLst>
-                                          <p:attrName>style.visibility</p:attrName>
-                                        </p:attrNameLst>
-                                      </p:cBhvr>
-                                      <p:to>
-                                        <p:strVal val="visible"/>
-                                      </p:to>
-                                    </p:set>
-                                  </p:childTnLst>
-                                </p:cTn>
-                              </p:par>
-                              <p:par>
-                                <p:cTn id="9" presetID="1" presetClass="entr" presetSubtype="0" fill="hold" grpId="0" nodeType="withEffect">
-                                  <p:stCondLst>
-                                    <p:cond delay="0"/>
-                                  </p:stCondLst>
-                                  <p:childTnLst>
-                                    <p:set>
-                                      <p:cBhvr>
-                                        <p:cTn id="10" dur="1" fill="hold">
-                                          <p:stCondLst>
-                                            <p:cond delay="0"/>
-                                          </p:stCondLst>
-                                        </p:cTn>
-                                        <p:tgtEl>
-                                          <p:spTgt spid="68"/>
-                                        </p:tgtEl>
-                                        <p:attrNameLst>
-                                          <p:attrName>style.visibility</p:attrName>
-                                        </p:attrNameLst>
-                                      </p:cBhvr>
-                                      <p:to>
-                                        <p:strVal val="visible"/>
-                                      </p:to>
-                                    </p:set>
-                                  </p:childTnLst>
-                                </p:cTn>
-                              </p:par>
-                              <p:par>
-                                <p:cTn id="11" presetID="1" presetClass="entr" presetSubtype="0" fill="hold" grpId="0" nodeType="withEffect">
-                                  <p:stCondLst>
-                                    <p:cond delay="0"/>
-                                  </p:stCondLst>
-                                  <p:childTnLst>
-                                    <p:set>
-                                      <p:cBhvr>
-                                        <p:cTn id="12" dur="1" fill="hold">
-                                          <p:stCondLst>
-                                            <p:cond delay="0"/>
-                                          </p:stCondLst>
-                                        </p:cTn>
-                                        <p:tgtEl>
-                                          <p:spTgt spid="13"/>
-                                        </p:tgtEl>
-                                        <p:attrNameLst>
-                                          <p:attrName>style.visibility</p:attrName>
-                                        </p:attrNameLst>
-                                      </p:cBhvr>
-                                      <p:to>
-                                        <p:strVal val="visible"/>
-                                      </p:to>
-                                    </p:set>
-                                  </p:childTnLst>
-                                </p:cTn>
-                              </p:par>
-                            </p:childTnLst>
-                          </p:cTn>
-                        </p:par>
-                      </p:childTnLst>
-                    </p:cTn>
-                  </p:par>
-                </p:childTnLst>
-              </p:cTn>
-              <p:prevCondLst>
-                <p:cond evt="onPrev" delay="0">
-                  <p:tgtEl>
-                    <p:sldTgt/>
-                  </p:tgtEl>
-                </p:cond>
-              </p:prevCondLst>
-              <p:nextCondLst>
-                <p:cond evt="onNext" delay="0">
-                  <p:tgtEl>
-                    <p:sldTgt/>
-                  </p:tgtEl>
-                </p:cond>
-              </p:nextCondLst>
-            </p:seq>
-          </p:childTnLst>
-        </p:cTn>
-      </p:par>
-    </p:tnLst>
-    <p:bldLst>
-      <p:bldP spid="68" grpId="0"/>
-      <p:bldP spid="74" grpId="0"/>
-      <p:bldP spid="77" grpId="0" animBg="1"/>
-      <p:bldP spid="13" grpId="0"/>
-    </p:bldLst>
-  </p:timing>
 </p:sld>
 </file>
 
@@ -42483,87 +41907,6 @@
   <p:clrMapOvr>
     <a:masterClrMapping/>
   </p:clrMapOvr>
-  <p:timing>
-    <p:tnLst>
-      <p:par>
-        <p:cTn id="1" dur="indefinite" restart="never" nodeType="tmRoot">
-          <p:childTnLst>
-            <p:seq concurrent="1" nextAc="seek">
-              <p:cTn id="2" dur="indefinite" nodeType="mainSeq">
-                <p:childTnLst>
-                  <p:par>
-                    <p:cTn id="3" fill="hold">
-                      <p:stCondLst>
-                        <p:cond delay="indefinite"/>
-                        <p:cond evt="onBegin" delay="0">
-                          <p:tn val="2"/>
-                        </p:cond>
-                      </p:stCondLst>
-                      <p:childTnLst>
-                        <p:par>
-                          <p:cTn id="4" fill="hold">
-                            <p:stCondLst>
-                              <p:cond delay="0"/>
-                            </p:stCondLst>
-                            <p:childTnLst>
-                              <p:par>
-                                <p:cTn id="5" presetID="1" presetClass="entr" presetSubtype="0" fill="hold" grpId="0" nodeType="withEffect">
-                                  <p:stCondLst>
-                                    <p:cond delay="0"/>
-                                  </p:stCondLst>
-                                  <p:childTnLst>
-                                    <p:set>
-                                      <p:cBhvr>
-                                        <p:cTn id="6" dur="1" fill="hold">
-                                          <p:stCondLst>
-                                            <p:cond delay="0"/>
-                                          </p:stCondLst>
-                                        </p:cTn>
-                                        <p:tgtEl>
-                                          <p:spTgt spid="2"/>
-                                        </p:tgtEl>
-                                        <p:attrNameLst>
-                                          <p:attrName>style.visibility</p:attrName>
-                                        </p:attrNameLst>
-                                      </p:cBhvr>
-                                      <p:to>
-                                        <p:strVal val="visible"/>
-                                      </p:to>
-                                    </p:set>
-                                  </p:childTnLst>
-                                </p:cTn>
-                              </p:par>
-                            </p:childTnLst>
-                          </p:cTn>
-                        </p:par>
-                      </p:childTnLst>
-                    </p:cTn>
-                  </p:par>
-                </p:childTnLst>
-              </p:cTn>
-              <p:prevCondLst>
-                <p:cond evt="onPrev" delay="0">
-                  <p:tgtEl>
-                    <p:sldTgt/>
-                  </p:tgtEl>
-                </p:cond>
-              </p:prevCondLst>
-              <p:nextCondLst>
-                <p:cond evt="onNext" delay="0">
-                  <p:tgtEl>
-                    <p:sldTgt/>
-                  </p:tgtEl>
-                </p:cond>
-              </p:nextCondLst>
-            </p:seq>
-          </p:childTnLst>
-        </p:cTn>
-      </p:par>
-    </p:tnLst>
-    <p:bldLst>
-      <p:bldP spid="2" grpId="0"/>
-    </p:bldLst>
-  </p:timing>
 </p:sld>
 </file>
 
@@ -44964,8 +44307,8 @@
           </a:p>
         </p:txBody>
       </p:sp>
-      <mc:AlternateContent xmlns:mc="http://schemas.openxmlformats.org/markup-compatibility/2006">
-        <mc:Choice xmlns:a14="http://schemas.microsoft.com/office/drawing/2010/main" Requires="a14">
+      <mc:AlternateContent xmlns:mc="http://schemas.openxmlformats.org/markup-compatibility/2006" xmlns:a14="http://schemas.microsoft.com/office/drawing/2010/main">
+        <mc:Choice Requires="a14">
           <p:sp>
             <p:nvSpPr>
               <p:cNvPr id="8" name="TextBox 7">
@@ -45229,7 +44572,7 @@
             </p:txBody>
           </p:sp>
         </mc:Choice>
-        <mc:Fallback>
+        <mc:Fallback xmlns="">
           <p:sp>
             <p:nvSpPr>
               <p:cNvPr id="8" name="TextBox 7">
@@ -45284,329 +44627,6 @@
   <p:clrMapOvr>
     <a:masterClrMapping/>
   </p:clrMapOvr>
-  <p:timing>
-    <p:tnLst>
-      <p:par>
-        <p:cTn id="1" dur="indefinite" restart="never" nodeType="tmRoot">
-          <p:childTnLst>
-            <p:seq concurrent="1" nextAc="seek">
-              <p:cTn id="2" dur="indefinite" nodeType="mainSeq">
-                <p:childTnLst>
-                  <p:par>
-                    <p:cTn id="3" fill="hold">
-                      <p:stCondLst>
-                        <p:cond delay="indefinite"/>
-                        <p:cond evt="onBegin" delay="0">
-                          <p:tn val="2"/>
-                        </p:cond>
-                      </p:stCondLst>
-                      <p:childTnLst>
-                        <p:par>
-                          <p:cTn id="4" fill="hold">
-                            <p:stCondLst>
-                              <p:cond delay="0"/>
-                            </p:stCondLst>
-                            <p:childTnLst>
-                              <p:par>
-                                <p:cTn id="5" presetID="1" presetClass="entr" presetSubtype="0" fill="hold" grpId="0" nodeType="withEffect">
-                                  <p:stCondLst>
-                                    <p:cond delay="0"/>
-                                  </p:stCondLst>
-                                  <p:childTnLst>
-                                    <p:set>
-                                      <p:cBhvr>
-                                        <p:cTn id="6" dur="1" fill="hold">
-                                          <p:stCondLst>
-                                            <p:cond delay="0"/>
-                                          </p:stCondLst>
-                                        </p:cTn>
-                                        <p:tgtEl>
-                                          <p:spTgt spid="32"/>
-                                        </p:tgtEl>
-                                        <p:attrNameLst>
-                                          <p:attrName>style.visibility</p:attrName>
-                                        </p:attrNameLst>
-                                      </p:cBhvr>
-                                      <p:to>
-                                        <p:strVal val="visible"/>
-                                      </p:to>
-                                    </p:set>
-                                  </p:childTnLst>
-                                </p:cTn>
-                              </p:par>
-                              <p:par>
-                                <p:cTn id="7" presetID="1" presetClass="entr" presetSubtype="0" fill="hold" grpId="0" nodeType="withEffect">
-                                  <p:stCondLst>
-                                    <p:cond delay="0"/>
-                                  </p:stCondLst>
-                                  <p:childTnLst>
-                                    <p:set>
-                                      <p:cBhvr>
-                                        <p:cTn id="8" dur="1" fill="hold">
-                                          <p:stCondLst>
-                                            <p:cond delay="0"/>
-                                          </p:stCondLst>
-                                        </p:cTn>
-                                        <p:tgtEl>
-                                          <p:spTgt spid="40"/>
-                                        </p:tgtEl>
-                                        <p:attrNameLst>
-                                          <p:attrName>style.visibility</p:attrName>
-                                        </p:attrNameLst>
-                                      </p:cBhvr>
-                                      <p:to>
-                                        <p:strVal val="visible"/>
-                                      </p:to>
-                                    </p:set>
-                                  </p:childTnLst>
-                                </p:cTn>
-                              </p:par>
-                              <p:par>
-                                <p:cTn id="9" presetID="1" presetClass="entr" presetSubtype="0" fill="hold" grpId="0" nodeType="withEffect">
-                                  <p:stCondLst>
-                                    <p:cond delay="0"/>
-                                  </p:stCondLst>
-                                  <p:childTnLst>
-                                    <p:set>
-                                      <p:cBhvr>
-                                        <p:cTn id="10" dur="1" fill="hold">
-                                          <p:stCondLst>
-                                            <p:cond delay="0"/>
-                                          </p:stCondLst>
-                                        </p:cTn>
-                                        <p:tgtEl>
-                                          <p:spTgt spid="41"/>
-                                        </p:tgtEl>
-                                        <p:attrNameLst>
-                                          <p:attrName>style.visibility</p:attrName>
-                                        </p:attrNameLst>
-                                      </p:cBhvr>
-                                      <p:to>
-                                        <p:strVal val="visible"/>
-                                      </p:to>
-                                    </p:set>
-                                  </p:childTnLst>
-                                </p:cTn>
-                              </p:par>
-                              <p:par>
-                                <p:cTn id="11" presetID="1" presetClass="entr" presetSubtype="0" fill="hold" grpId="0" nodeType="withEffect">
-                                  <p:stCondLst>
-                                    <p:cond delay="0"/>
-                                  </p:stCondLst>
-                                  <p:childTnLst>
-                                    <p:set>
-                                      <p:cBhvr>
-                                        <p:cTn id="12" dur="1" fill="hold">
-                                          <p:stCondLst>
-                                            <p:cond delay="0"/>
-                                          </p:stCondLst>
-                                        </p:cTn>
-                                        <p:tgtEl>
-                                          <p:spTgt spid="42"/>
-                                        </p:tgtEl>
-                                        <p:attrNameLst>
-                                          <p:attrName>style.visibility</p:attrName>
-                                        </p:attrNameLst>
-                                      </p:cBhvr>
-                                      <p:to>
-                                        <p:strVal val="visible"/>
-                                      </p:to>
-                                    </p:set>
-                                  </p:childTnLst>
-                                </p:cTn>
-                              </p:par>
-                              <p:par>
-                                <p:cTn id="13" presetID="1" presetClass="entr" presetSubtype="0" fill="hold" grpId="0" nodeType="withEffect">
-                                  <p:stCondLst>
-                                    <p:cond delay="0"/>
-                                  </p:stCondLst>
-                                  <p:childTnLst>
-                                    <p:set>
-                                      <p:cBhvr>
-                                        <p:cTn id="14" dur="1" fill="hold">
-                                          <p:stCondLst>
-                                            <p:cond delay="0"/>
-                                          </p:stCondLst>
-                                        </p:cTn>
-                                        <p:tgtEl>
-                                          <p:spTgt spid="43"/>
-                                        </p:tgtEl>
-                                        <p:attrNameLst>
-                                          <p:attrName>style.visibility</p:attrName>
-                                        </p:attrNameLst>
-                                      </p:cBhvr>
-                                      <p:to>
-                                        <p:strVal val="visible"/>
-                                      </p:to>
-                                    </p:set>
-                                  </p:childTnLst>
-                                </p:cTn>
-                              </p:par>
-                              <p:par>
-                                <p:cTn id="15" presetID="1" presetClass="entr" presetSubtype="0" fill="hold" grpId="0" nodeType="withEffect">
-                                  <p:stCondLst>
-                                    <p:cond delay="0"/>
-                                  </p:stCondLst>
-                                  <p:childTnLst>
-                                    <p:set>
-                                      <p:cBhvr>
-                                        <p:cTn id="16" dur="1" fill="hold">
-                                          <p:stCondLst>
-                                            <p:cond delay="0"/>
-                                          </p:stCondLst>
-                                        </p:cTn>
-                                        <p:tgtEl>
-                                          <p:spTgt spid="44"/>
-                                        </p:tgtEl>
-                                        <p:attrNameLst>
-                                          <p:attrName>style.visibility</p:attrName>
-                                        </p:attrNameLst>
-                                      </p:cBhvr>
-                                      <p:to>
-                                        <p:strVal val="visible"/>
-                                      </p:to>
-                                    </p:set>
-                                  </p:childTnLst>
-                                </p:cTn>
-                              </p:par>
-                              <p:par>
-                                <p:cTn id="17" presetID="1" presetClass="entr" presetSubtype="0" fill="hold" grpId="0" nodeType="withEffect">
-                                  <p:stCondLst>
-                                    <p:cond delay="0"/>
-                                  </p:stCondLst>
-                                  <p:childTnLst>
-                                    <p:set>
-                                      <p:cBhvr>
-                                        <p:cTn id="18" dur="1" fill="hold">
-                                          <p:stCondLst>
-                                            <p:cond delay="0"/>
-                                          </p:stCondLst>
-                                        </p:cTn>
-                                        <p:tgtEl>
-                                          <p:spTgt spid="45"/>
-                                        </p:tgtEl>
-                                        <p:attrNameLst>
-                                          <p:attrName>style.visibility</p:attrName>
-                                        </p:attrNameLst>
-                                      </p:cBhvr>
-                                      <p:to>
-                                        <p:strVal val="visible"/>
-                                      </p:to>
-                                    </p:set>
-                                  </p:childTnLst>
-                                </p:cTn>
-                              </p:par>
-                              <p:par>
-                                <p:cTn id="19" presetID="1" presetClass="entr" presetSubtype="0" fill="hold" grpId="0" nodeType="withEffect">
-                                  <p:stCondLst>
-                                    <p:cond delay="0"/>
-                                  </p:stCondLst>
-                                  <p:childTnLst>
-                                    <p:set>
-                                      <p:cBhvr>
-                                        <p:cTn id="20" dur="1" fill="hold">
-                                          <p:stCondLst>
-                                            <p:cond delay="0"/>
-                                          </p:stCondLst>
-                                        </p:cTn>
-                                        <p:tgtEl>
-                                          <p:spTgt spid="46"/>
-                                        </p:tgtEl>
-                                        <p:attrNameLst>
-                                          <p:attrName>style.visibility</p:attrName>
-                                        </p:attrNameLst>
-                                      </p:cBhvr>
-                                      <p:to>
-                                        <p:strVal val="visible"/>
-                                      </p:to>
-                                    </p:set>
-                                  </p:childTnLst>
-                                </p:cTn>
-                              </p:par>
-                            </p:childTnLst>
-                          </p:cTn>
-                        </p:par>
-                      </p:childTnLst>
-                    </p:cTn>
-                  </p:par>
-                  <p:par>
-                    <p:cTn id="21" fill="hold">
-                      <p:stCondLst>
-                        <p:cond delay="indefinite"/>
-                      </p:stCondLst>
-                      <p:childTnLst>
-                        <p:par>
-                          <p:cTn id="22" fill="hold">
-                            <p:stCondLst>
-                              <p:cond delay="0"/>
-                            </p:stCondLst>
-                            <p:childTnLst>
-                              <p:par>
-                                <p:cTn id="23" presetID="1" presetClass="entr" presetSubtype="0" fill="hold" grpId="0" nodeType="clickEffect">
-                                  <p:stCondLst>
-                                    <p:cond delay="0"/>
-                                  </p:stCondLst>
-                                  <p:childTnLst>
-                                    <p:set>
-                                      <p:cBhvr>
-                                        <p:cTn id="24" dur="1" fill="hold">
-                                          <p:stCondLst>
-                                            <p:cond delay="0"/>
-                                          </p:stCondLst>
-                                        </p:cTn>
-                                        <p:tgtEl>
-                                          <p:spTgt spid="47"/>
-                                        </p:tgtEl>
-                                        <p:attrNameLst>
-                                          <p:attrName>style.visibility</p:attrName>
-                                        </p:attrNameLst>
-                                      </p:cBhvr>
-                                      <p:to>
-                                        <p:strVal val="visible"/>
-                                      </p:to>
-                                    </p:set>
-                                  </p:childTnLst>
-                                </p:cTn>
-                              </p:par>
-                            </p:childTnLst>
-                          </p:cTn>
-                        </p:par>
-                      </p:childTnLst>
-                    </p:cTn>
-                  </p:par>
-                </p:childTnLst>
-              </p:cTn>
-              <p:prevCondLst>
-                <p:cond evt="onPrev" delay="0">
-                  <p:tgtEl>
-                    <p:sldTgt/>
-                  </p:tgtEl>
-                </p:cond>
-              </p:prevCondLst>
-              <p:nextCondLst>
-                <p:cond evt="onNext" delay="0">
-                  <p:tgtEl>
-                    <p:sldTgt/>
-                  </p:tgtEl>
-                </p:cond>
-              </p:nextCondLst>
-            </p:seq>
-          </p:childTnLst>
-        </p:cTn>
-      </p:par>
-    </p:tnLst>
-    <p:bldLst>
-      <p:bldP spid="32" grpId="0" animBg="1"/>
-      <p:bldP spid="40" grpId="0"/>
-      <p:bldP spid="41" grpId="0"/>
-      <p:bldP spid="42" grpId="0"/>
-      <p:bldP spid="43" grpId="0"/>
-      <p:bldP spid="44" grpId="0"/>
-      <p:bldP spid="45" grpId="0"/>
-      <p:bldP spid="46" grpId="0"/>
-      <p:bldP spid="47" grpId="0" animBg="1"/>
-    </p:bldLst>
-  </p:timing>
 </p:sld>
 </file>
 
@@ -45713,8 +44733,8 @@
           </a:p>
         </p:txBody>
       </p:sp>
-      <mc:AlternateContent xmlns:mc="http://schemas.openxmlformats.org/markup-compatibility/2006">
-        <mc:Choice xmlns:a14="http://schemas.microsoft.com/office/drawing/2010/main" Requires="a14">
+      <mc:AlternateContent xmlns:mc="http://schemas.openxmlformats.org/markup-compatibility/2006" xmlns:a14="http://schemas.microsoft.com/office/drawing/2010/main">
+        <mc:Choice Requires="a14">
           <p:sp>
             <p:nvSpPr>
               <p:cNvPr id="46" name="TextBox 45">
@@ -45935,7 +44955,7 @@
             </p:txBody>
           </p:sp>
         </mc:Choice>
-        <mc:Fallback>
+        <mc:Fallback xmlns="">
           <p:sp>
             <p:nvSpPr>
               <p:cNvPr id="46" name="TextBox 45">
@@ -46076,8 +45096,8 @@
           </p:sp>
         </mc:Fallback>
       </mc:AlternateContent>
-      <mc:AlternateContent xmlns:mc="http://schemas.openxmlformats.org/markup-compatibility/2006">
-        <mc:Choice xmlns:a14="http://schemas.microsoft.com/office/drawing/2010/main" Requires="a14">
+      <mc:AlternateContent xmlns:mc="http://schemas.openxmlformats.org/markup-compatibility/2006" xmlns:a14="http://schemas.microsoft.com/office/drawing/2010/main">
+        <mc:Choice Requires="a14">
           <p:sp>
             <p:nvSpPr>
               <p:cNvPr id="49" name="TextBox 48">
@@ -46331,7 +45351,7 @@
             </p:txBody>
           </p:sp>
         </mc:Choice>
-        <mc:Fallback>
+        <mc:Fallback xmlns="">
           <p:sp>
             <p:nvSpPr>
               <p:cNvPr id="49" name="TextBox 48">
@@ -46376,8 +45396,8 @@
           </p:sp>
         </mc:Fallback>
       </mc:AlternateContent>
-      <mc:AlternateContent xmlns:mc="http://schemas.openxmlformats.org/markup-compatibility/2006">
-        <mc:Choice xmlns:a14="http://schemas.microsoft.com/office/drawing/2010/main" Requires="a14">
+      <mc:AlternateContent xmlns:mc="http://schemas.openxmlformats.org/markup-compatibility/2006" xmlns:a14="http://schemas.microsoft.com/office/drawing/2010/main">
+        <mc:Choice Requires="a14">
           <p:sp>
             <p:nvSpPr>
               <p:cNvPr id="50" name="TextBox 49">
@@ -46444,7 +45464,7 @@
             </p:txBody>
           </p:sp>
         </mc:Choice>
-        <mc:Fallback>
+        <mc:Fallback xmlns="">
           <p:sp>
             <p:nvSpPr>
               <p:cNvPr id="50" name="TextBox 49">
@@ -47498,8 +46518,8 @@
           </a:prstGeom>
         </p:spPr>
       </p:pic>
-      <mc:AlternateContent xmlns:mc="http://schemas.openxmlformats.org/markup-compatibility/2006">
-        <mc:Choice xmlns:a14="http://schemas.microsoft.com/office/drawing/2010/main" Requires="a14">
+      <mc:AlternateContent xmlns:mc="http://schemas.openxmlformats.org/markup-compatibility/2006" xmlns:a14="http://schemas.microsoft.com/office/drawing/2010/main">
+        <mc:Choice Requires="a14">
           <p:sp>
             <p:nvSpPr>
               <p:cNvPr id="6" name="TextBox 5">
@@ -47566,7 +46586,7 @@
             </p:txBody>
           </p:sp>
         </mc:Choice>
-        <mc:Fallback>
+        <mc:Fallback xmlns="">
           <p:sp>
             <p:nvSpPr>
               <p:cNvPr id="6" name="TextBox 5">
@@ -47611,8 +46631,8 @@
           </p:sp>
         </mc:Fallback>
       </mc:AlternateContent>
-      <mc:AlternateContent xmlns:mc="http://schemas.openxmlformats.org/markup-compatibility/2006">
-        <mc:Choice xmlns:a14="http://schemas.microsoft.com/office/drawing/2010/main" Requires="a14">
+      <mc:AlternateContent xmlns:mc="http://schemas.openxmlformats.org/markup-compatibility/2006" xmlns:a14="http://schemas.microsoft.com/office/drawing/2010/main">
+        <mc:Choice Requires="a14">
           <p:sp>
             <p:nvSpPr>
               <p:cNvPr id="8" name="TextBox 7">
@@ -47662,7 +46682,7 @@
             </p:txBody>
           </p:sp>
         </mc:Choice>
-        <mc:Fallback>
+        <mc:Fallback xmlns="">
           <p:sp>
             <p:nvSpPr>
               <p:cNvPr id="8" name="TextBox 7">
@@ -47717,382 +46737,6 @@
   <p:clrMapOvr>
     <a:masterClrMapping/>
   </p:clrMapOvr>
-  <p:timing>
-    <p:tnLst>
-      <p:par>
-        <p:cTn id="1" dur="indefinite" restart="never" nodeType="tmRoot">
-          <p:childTnLst>
-            <p:seq concurrent="1" nextAc="seek">
-              <p:cTn id="2" dur="indefinite" nodeType="mainSeq">
-                <p:childTnLst>
-                  <p:par>
-                    <p:cTn id="3" fill="hold">
-                      <p:stCondLst>
-                        <p:cond delay="indefinite"/>
-                      </p:stCondLst>
-                      <p:childTnLst>
-                        <p:par>
-                          <p:cTn id="4" fill="hold">
-                            <p:stCondLst>
-                              <p:cond delay="0"/>
-                            </p:stCondLst>
-                            <p:childTnLst>
-                              <p:par>
-                                <p:cTn id="5" presetID="1" presetClass="entr" presetSubtype="0" fill="hold" grpId="0" nodeType="clickEffect">
-                                  <p:stCondLst>
-                                    <p:cond delay="0"/>
-                                  </p:stCondLst>
-                                  <p:childTnLst>
-                                    <p:set>
-                                      <p:cBhvr>
-                                        <p:cTn id="6" dur="1" fill="hold">
-                                          <p:stCondLst>
-                                            <p:cond delay="0"/>
-                                          </p:stCondLst>
-                                        </p:cTn>
-                                        <p:tgtEl>
-                                          <p:spTgt spid="33"/>
-                                        </p:tgtEl>
-                                        <p:attrNameLst>
-                                          <p:attrName>style.visibility</p:attrName>
-                                        </p:attrNameLst>
-                                      </p:cBhvr>
-                                      <p:to>
-                                        <p:strVal val="visible"/>
-                                      </p:to>
-                                    </p:set>
-                                  </p:childTnLst>
-                                </p:cTn>
-                              </p:par>
-                              <p:par>
-                                <p:cTn id="7" presetID="1" presetClass="entr" presetSubtype="0" fill="hold" grpId="0" nodeType="withEffect">
-                                  <p:stCondLst>
-                                    <p:cond delay="0"/>
-                                  </p:stCondLst>
-                                  <p:childTnLst>
-                                    <p:set>
-                                      <p:cBhvr>
-                                        <p:cTn id="8" dur="1" fill="hold">
-                                          <p:stCondLst>
-                                            <p:cond delay="0"/>
-                                          </p:stCondLst>
-                                        </p:cTn>
-                                        <p:tgtEl>
-                                          <p:spTgt spid="46"/>
-                                        </p:tgtEl>
-                                        <p:attrNameLst>
-                                          <p:attrName>style.visibility</p:attrName>
-                                        </p:attrNameLst>
-                                      </p:cBhvr>
-                                      <p:to>
-                                        <p:strVal val="visible"/>
-                                      </p:to>
-                                    </p:set>
-                                  </p:childTnLst>
-                                </p:cTn>
-                              </p:par>
-                              <p:par>
-                                <p:cTn id="9" presetID="1" presetClass="entr" presetSubtype="0" fill="hold" grpId="0" nodeType="withEffect">
-                                  <p:stCondLst>
-                                    <p:cond delay="0"/>
-                                  </p:stCondLst>
-                                  <p:childTnLst>
-                                    <p:set>
-                                      <p:cBhvr>
-                                        <p:cTn id="10" dur="1" fill="hold">
-                                          <p:stCondLst>
-                                            <p:cond delay="0"/>
-                                          </p:stCondLst>
-                                        </p:cTn>
-                                        <p:tgtEl>
-                                          <p:spTgt spid="48"/>
-                                        </p:tgtEl>
-                                        <p:attrNameLst>
-                                          <p:attrName>style.visibility</p:attrName>
-                                        </p:attrNameLst>
-                                      </p:cBhvr>
-                                      <p:to>
-                                        <p:strVal val="visible"/>
-                                      </p:to>
-                                    </p:set>
-                                  </p:childTnLst>
-                                </p:cTn>
-                              </p:par>
-                              <p:par>
-                                <p:cTn id="11" presetID="1" presetClass="entr" presetSubtype="0" fill="hold" grpId="0" nodeType="withEffect">
-                                  <p:stCondLst>
-                                    <p:cond delay="0"/>
-                                  </p:stCondLst>
-                                  <p:childTnLst>
-                                    <p:set>
-                                      <p:cBhvr>
-                                        <p:cTn id="12" dur="1" fill="hold">
-                                          <p:stCondLst>
-                                            <p:cond delay="0"/>
-                                          </p:stCondLst>
-                                        </p:cTn>
-                                        <p:tgtEl>
-                                          <p:spTgt spid="49"/>
-                                        </p:tgtEl>
-                                        <p:attrNameLst>
-                                          <p:attrName>style.visibility</p:attrName>
-                                        </p:attrNameLst>
-                                      </p:cBhvr>
-                                      <p:to>
-                                        <p:strVal val="visible"/>
-                                      </p:to>
-                                    </p:set>
-                                  </p:childTnLst>
-                                </p:cTn>
-                              </p:par>
-                              <p:par>
-                                <p:cTn id="13" presetID="1" presetClass="entr" presetSubtype="0" fill="hold" grpId="0" nodeType="withEffect">
-                                  <p:stCondLst>
-                                    <p:cond delay="0"/>
-                                  </p:stCondLst>
-                                  <p:childTnLst>
-                                    <p:set>
-                                      <p:cBhvr>
-                                        <p:cTn id="14" dur="1" fill="hold">
-                                          <p:stCondLst>
-                                            <p:cond delay="0"/>
-                                          </p:stCondLst>
-                                        </p:cTn>
-                                        <p:tgtEl>
-                                          <p:spTgt spid="50"/>
-                                        </p:tgtEl>
-                                        <p:attrNameLst>
-                                          <p:attrName>style.visibility</p:attrName>
-                                        </p:attrNameLst>
-                                      </p:cBhvr>
-                                      <p:to>
-                                        <p:strVal val="visible"/>
-                                      </p:to>
-                                    </p:set>
-                                  </p:childTnLst>
-                                </p:cTn>
-                              </p:par>
-                              <p:par>
-                                <p:cTn id="15" presetID="1" presetClass="entr" presetSubtype="0" fill="hold" grpId="0" nodeType="withEffect">
-                                  <p:stCondLst>
-                                    <p:cond delay="0"/>
-                                  </p:stCondLst>
-                                  <p:childTnLst>
-                                    <p:set>
-                                      <p:cBhvr>
-                                        <p:cTn id="16" dur="1" fill="hold">
-                                          <p:stCondLst>
-                                            <p:cond delay="0"/>
-                                          </p:stCondLst>
-                                        </p:cTn>
-                                        <p:tgtEl>
-                                          <p:spTgt spid="56"/>
-                                        </p:tgtEl>
-                                        <p:attrNameLst>
-                                          <p:attrName>style.visibility</p:attrName>
-                                        </p:attrNameLst>
-                                      </p:cBhvr>
-                                      <p:to>
-                                        <p:strVal val="visible"/>
-                                      </p:to>
-                                    </p:set>
-                                  </p:childTnLst>
-                                </p:cTn>
-                              </p:par>
-                              <p:par>
-                                <p:cTn id="17" presetID="1" presetClass="entr" presetSubtype="0" fill="hold" grpId="0" nodeType="withEffect">
-                                  <p:stCondLst>
-                                    <p:cond delay="0"/>
-                                  </p:stCondLst>
-                                  <p:childTnLst>
-                                    <p:set>
-                                      <p:cBhvr>
-                                        <p:cTn id="18" dur="1" fill="hold">
-                                          <p:stCondLst>
-                                            <p:cond delay="0"/>
-                                          </p:stCondLst>
-                                        </p:cTn>
-                                        <p:tgtEl>
-                                          <p:spTgt spid="59"/>
-                                        </p:tgtEl>
-                                        <p:attrNameLst>
-                                          <p:attrName>style.visibility</p:attrName>
-                                        </p:attrNameLst>
-                                      </p:cBhvr>
-                                      <p:to>
-                                        <p:strVal val="visible"/>
-                                      </p:to>
-                                    </p:set>
-                                  </p:childTnLst>
-                                </p:cTn>
-                              </p:par>
-                              <p:par>
-                                <p:cTn id="19" presetID="1" presetClass="entr" presetSubtype="0" fill="hold" grpId="0" nodeType="withEffect">
-                                  <p:stCondLst>
-                                    <p:cond delay="0"/>
-                                  </p:stCondLst>
-                                  <p:childTnLst>
-                                    <p:set>
-                                      <p:cBhvr>
-                                        <p:cTn id="20" dur="1" fill="hold">
-                                          <p:stCondLst>
-                                            <p:cond delay="0"/>
-                                          </p:stCondLst>
-                                        </p:cTn>
-                                        <p:tgtEl>
-                                          <p:spTgt spid="60"/>
-                                        </p:tgtEl>
-                                        <p:attrNameLst>
-                                          <p:attrName>style.visibility</p:attrName>
-                                        </p:attrNameLst>
-                                      </p:cBhvr>
-                                      <p:to>
-                                        <p:strVal val="visible"/>
-                                      </p:to>
-                                    </p:set>
-                                  </p:childTnLst>
-                                </p:cTn>
-                              </p:par>
-                              <p:par>
-                                <p:cTn id="21" presetID="1" presetClass="entr" presetSubtype="0" fill="hold" grpId="0" nodeType="withEffect">
-                                  <p:stCondLst>
-                                    <p:cond delay="0"/>
-                                  </p:stCondLst>
-                                  <p:childTnLst>
-                                    <p:set>
-                                      <p:cBhvr>
-                                        <p:cTn id="22" dur="1" fill="hold">
-                                          <p:stCondLst>
-                                            <p:cond delay="0"/>
-                                          </p:stCondLst>
-                                        </p:cTn>
-                                        <p:tgtEl>
-                                          <p:spTgt spid="61"/>
-                                        </p:tgtEl>
-                                        <p:attrNameLst>
-                                          <p:attrName>style.visibility</p:attrName>
-                                        </p:attrNameLst>
-                                      </p:cBhvr>
-                                      <p:to>
-                                        <p:strVal val="visible"/>
-                                      </p:to>
-                                    </p:set>
-                                  </p:childTnLst>
-                                </p:cTn>
-                              </p:par>
-                              <p:par>
-                                <p:cTn id="23" presetID="1" presetClass="entr" presetSubtype="0" fill="hold" grpId="0" nodeType="withEffect">
-                                  <p:stCondLst>
-                                    <p:cond delay="0"/>
-                                  </p:stCondLst>
-                                  <p:childTnLst>
-                                    <p:set>
-                                      <p:cBhvr>
-                                        <p:cTn id="24" dur="1" fill="hold">
-                                          <p:stCondLst>
-                                            <p:cond delay="0"/>
-                                          </p:stCondLst>
-                                        </p:cTn>
-                                        <p:tgtEl>
-                                          <p:spTgt spid="62"/>
-                                        </p:tgtEl>
-                                        <p:attrNameLst>
-                                          <p:attrName>style.visibility</p:attrName>
-                                        </p:attrNameLst>
-                                      </p:cBhvr>
-                                      <p:to>
-                                        <p:strVal val="visible"/>
-                                      </p:to>
-                                    </p:set>
-                                  </p:childTnLst>
-                                </p:cTn>
-                              </p:par>
-                            </p:childTnLst>
-                          </p:cTn>
-                        </p:par>
-                      </p:childTnLst>
-                    </p:cTn>
-                  </p:par>
-                  <p:par>
-                    <p:cTn id="25" fill="hold">
-                      <p:stCondLst>
-                        <p:cond delay="indefinite"/>
-                      </p:stCondLst>
-                      <p:childTnLst>
-                        <p:par>
-                          <p:cTn id="26" fill="hold">
-                            <p:stCondLst>
-                              <p:cond delay="0"/>
-                            </p:stCondLst>
-                            <p:childTnLst>
-                              <p:par>
-                                <p:cTn id="27" presetID="1" presetClass="entr" presetSubtype="0" fill="hold" grpId="0" nodeType="clickEffect">
-                                  <p:stCondLst>
-                                    <p:cond delay="0"/>
-                                  </p:stCondLst>
-                                  <p:childTnLst>
-                                    <p:set>
-                                      <p:cBhvr>
-                                        <p:cTn id="28" dur="1" fill="hold">
-                                          <p:stCondLst>
-                                            <p:cond delay="0"/>
-                                          </p:stCondLst>
-                                        </p:cTn>
-                                        <p:tgtEl>
-                                          <p:spTgt spid="63"/>
-                                        </p:tgtEl>
-                                        <p:attrNameLst>
-                                          <p:attrName>style.visibility</p:attrName>
-                                        </p:attrNameLst>
-                                      </p:cBhvr>
-                                      <p:to>
-                                        <p:strVal val="visible"/>
-                                      </p:to>
-                                    </p:set>
-                                  </p:childTnLst>
-                                </p:cTn>
-                              </p:par>
-                            </p:childTnLst>
-                          </p:cTn>
-                        </p:par>
-                      </p:childTnLst>
-                    </p:cTn>
-                  </p:par>
-                </p:childTnLst>
-              </p:cTn>
-              <p:prevCondLst>
-                <p:cond evt="onPrev" delay="0">
-                  <p:tgtEl>
-                    <p:sldTgt/>
-                  </p:tgtEl>
-                </p:cond>
-              </p:prevCondLst>
-              <p:nextCondLst>
-                <p:cond evt="onNext" delay="0">
-                  <p:tgtEl>
-                    <p:sldTgt/>
-                  </p:tgtEl>
-                </p:cond>
-              </p:nextCondLst>
-            </p:seq>
-          </p:childTnLst>
-        </p:cTn>
-      </p:par>
-    </p:tnLst>
-    <p:bldLst>
-      <p:bldP spid="33" grpId="0" animBg="1"/>
-      <p:bldP spid="46" grpId="0"/>
-      <p:bldP spid="48" grpId="0"/>
-      <p:bldP spid="49" grpId="0"/>
-      <p:bldP spid="50" grpId="0"/>
-      <p:bldP spid="56" grpId="0" animBg="1"/>
-      <p:bldP spid="59" grpId="0"/>
-      <p:bldP spid="60" grpId="0"/>
-      <p:bldP spid="61" grpId="0"/>
-      <p:bldP spid="62" grpId="0"/>
-      <p:bldP spid="63" grpId="0" animBg="1"/>
-    </p:bldLst>
-  </p:timing>
 </p:sld>
 </file>
 
@@ -48259,8 +46903,8 @@
           </p:sp>
         </mc:Fallback>
       </mc:AlternateContent>
-      <mc:AlternateContent xmlns:mc="http://schemas.openxmlformats.org/markup-compatibility/2006">
-        <mc:Choice xmlns:a14="http://schemas.microsoft.com/office/drawing/2010/main" Requires="a14">
+      <mc:AlternateContent xmlns:mc="http://schemas.openxmlformats.org/markup-compatibility/2006" xmlns:a14="http://schemas.microsoft.com/office/drawing/2010/main">
+        <mc:Choice Requires="a14">
           <p:sp>
             <p:nvSpPr>
               <p:cNvPr id="50" name="TextBox 49">
@@ -48289,7 +46933,6 @@
               </a:bodyPr>
               <a:lstStyle/>
               <a:p>
-                <a:pPr/>
                 <a14:m>
                   <m:oMath xmlns:m="http://schemas.openxmlformats.org/officeDocument/2006/math">
                     <m:r>
@@ -48424,13 +47067,7 @@
                           <a:rPr lang="en-US" sz="3200" i="1">
                             <a:latin typeface="Cambria Math" panose="02040503050406030204" pitchFamily="18" charset="0"/>
                           </a:rPr>
-                          <m:t>1</m:t>
-                        </m:r>
-                        <m:r>
-                          <a:rPr lang="en-US" sz="3200" i="1">
-                            <a:latin typeface="Cambria Math" panose="02040503050406030204" pitchFamily="18" charset="0"/>
-                          </a:rPr>
-                          <m:t>−</m:t>
+                          <m:t>1−</m:t>
                         </m:r>
                         <m:r>
                           <a:rPr lang="en-US" sz="3200" i="1">
@@ -48511,7 +47148,7 @@
             </p:txBody>
           </p:sp>
         </mc:Choice>
-        <mc:Fallback>
+        <mc:Fallback xmlns="">
           <p:sp>
             <p:nvSpPr>
               <p:cNvPr id="50" name="TextBox 49">
@@ -49657,326 +48294,6 @@
   <p:clrMapOvr>
     <a:masterClrMapping/>
   </p:clrMapOvr>
-  <p:timing>
-    <p:tnLst>
-      <p:par>
-        <p:cTn id="1" dur="indefinite" restart="never" nodeType="tmRoot">
-          <p:childTnLst>
-            <p:seq concurrent="1" nextAc="seek">
-              <p:cTn id="2" dur="indefinite" nodeType="mainSeq">
-                <p:childTnLst>
-                  <p:par>
-                    <p:cTn id="3" fill="hold">
-                      <p:stCondLst>
-                        <p:cond delay="indefinite"/>
-                      </p:stCondLst>
-                      <p:childTnLst>
-                        <p:par>
-                          <p:cTn id="4" fill="hold">
-                            <p:stCondLst>
-                              <p:cond delay="0"/>
-                            </p:stCondLst>
-                            <p:childTnLst>
-                              <p:par>
-                                <p:cTn id="5" presetID="1" presetClass="entr" presetSubtype="0" fill="hold" grpId="0" nodeType="clickEffect">
-                                  <p:stCondLst>
-                                    <p:cond delay="0"/>
-                                  </p:stCondLst>
-                                  <p:childTnLst>
-                                    <p:set>
-                                      <p:cBhvr>
-                                        <p:cTn id="6" dur="1" fill="hold">
-                                          <p:stCondLst>
-                                            <p:cond delay="0"/>
-                                          </p:stCondLst>
-                                        </p:cTn>
-                                        <p:tgtEl>
-                                          <p:spTgt spid="33"/>
-                                        </p:tgtEl>
-                                        <p:attrNameLst>
-                                          <p:attrName>style.visibility</p:attrName>
-                                        </p:attrNameLst>
-                                      </p:cBhvr>
-                                      <p:to>
-                                        <p:strVal val="visible"/>
-                                      </p:to>
-                                    </p:set>
-                                  </p:childTnLst>
-                                </p:cTn>
-                              </p:par>
-                              <p:par>
-                                <p:cTn id="7" presetID="1" presetClass="entr" presetSubtype="0" fill="hold" grpId="0" nodeType="withEffect">
-                                  <p:stCondLst>
-                                    <p:cond delay="0"/>
-                                  </p:stCondLst>
-                                  <p:childTnLst>
-                                    <p:set>
-                                      <p:cBhvr>
-                                        <p:cTn id="8" dur="1" fill="hold">
-                                          <p:stCondLst>
-                                            <p:cond delay="0"/>
-                                          </p:stCondLst>
-                                        </p:cTn>
-                                        <p:tgtEl>
-                                          <p:spTgt spid="48"/>
-                                        </p:tgtEl>
-                                        <p:attrNameLst>
-                                          <p:attrName>style.visibility</p:attrName>
-                                        </p:attrNameLst>
-                                      </p:cBhvr>
-                                      <p:to>
-                                        <p:strVal val="visible"/>
-                                      </p:to>
-                                    </p:set>
-                                  </p:childTnLst>
-                                </p:cTn>
-                              </p:par>
-                              <p:par>
-                                <p:cTn id="9" presetID="1" presetClass="entr" presetSubtype="0" fill="hold" grpId="0" nodeType="withEffect">
-                                  <p:stCondLst>
-                                    <p:cond delay="0"/>
-                                  </p:stCondLst>
-                                  <p:childTnLst>
-                                    <p:set>
-                                      <p:cBhvr>
-                                        <p:cTn id="10" dur="1" fill="hold">
-                                          <p:stCondLst>
-                                            <p:cond delay="0"/>
-                                          </p:stCondLst>
-                                        </p:cTn>
-                                        <p:tgtEl>
-                                          <p:spTgt spid="50"/>
-                                        </p:tgtEl>
-                                        <p:attrNameLst>
-                                          <p:attrName>style.visibility</p:attrName>
-                                        </p:attrNameLst>
-                                      </p:cBhvr>
-                                      <p:to>
-                                        <p:strVal val="visible"/>
-                                      </p:to>
-                                    </p:set>
-                                  </p:childTnLst>
-                                </p:cTn>
-                              </p:par>
-                              <p:par>
-                                <p:cTn id="11" presetID="1" presetClass="entr" presetSubtype="0" fill="hold" grpId="0" nodeType="withEffect">
-                                  <p:stCondLst>
-                                    <p:cond delay="0"/>
-                                  </p:stCondLst>
-                                  <p:childTnLst>
-                                    <p:set>
-                                      <p:cBhvr>
-                                        <p:cTn id="12" dur="1" fill="hold">
-                                          <p:stCondLst>
-                                            <p:cond delay="0"/>
-                                          </p:stCondLst>
-                                        </p:cTn>
-                                        <p:tgtEl>
-                                          <p:spTgt spid="56"/>
-                                        </p:tgtEl>
-                                        <p:attrNameLst>
-                                          <p:attrName>style.visibility</p:attrName>
-                                        </p:attrNameLst>
-                                      </p:cBhvr>
-                                      <p:to>
-                                        <p:strVal val="visible"/>
-                                      </p:to>
-                                    </p:set>
-                                  </p:childTnLst>
-                                </p:cTn>
-                              </p:par>
-                              <p:par>
-                                <p:cTn id="13" presetID="1" presetClass="entr" presetSubtype="0" fill="hold" grpId="0" nodeType="withEffect">
-                                  <p:stCondLst>
-                                    <p:cond delay="0"/>
-                                  </p:stCondLst>
-                                  <p:childTnLst>
-                                    <p:set>
-                                      <p:cBhvr>
-                                        <p:cTn id="14" dur="1" fill="hold">
-                                          <p:stCondLst>
-                                            <p:cond delay="0"/>
-                                          </p:stCondLst>
-                                        </p:cTn>
-                                        <p:tgtEl>
-                                          <p:spTgt spid="59"/>
-                                        </p:tgtEl>
-                                        <p:attrNameLst>
-                                          <p:attrName>style.visibility</p:attrName>
-                                        </p:attrNameLst>
-                                      </p:cBhvr>
-                                      <p:to>
-                                        <p:strVal val="visible"/>
-                                      </p:to>
-                                    </p:set>
-                                  </p:childTnLst>
-                                </p:cTn>
-                              </p:par>
-                              <p:par>
-                                <p:cTn id="15" presetID="1" presetClass="entr" presetSubtype="0" fill="hold" grpId="0" nodeType="withEffect">
-                                  <p:stCondLst>
-                                    <p:cond delay="0"/>
-                                  </p:stCondLst>
-                                  <p:childTnLst>
-                                    <p:set>
-                                      <p:cBhvr>
-                                        <p:cTn id="16" dur="1" fill="hold">
-                                          <p:stCondLst>
-                                            <p:cond delay="0"/>
-                                          </p:stCondLst>
-                                        </p:cTn>
-                                        <p:tgtEl>
-                                          <p:spTgt spid="60"/>
-                                        </p:tgtEl>
-                                        <p:attrNameLst>
-                                          <p:attrName>style.visibility</p:attrName>
-                                        </p:attrNameLst>
-                                      </p:cBhvr>
-                                      <p:to>
-                                        <p:strVal val="visible"/>
-                                      </p:to>
-                                    </p:set>
-                                  </p:childTnLst>
-                                </p:cTn>
-                              </p:par>
-                              <p:par>
-                                <p:cTn id="17" presetID="1" presetClass="entr" presetSubtype="0" fill="hold" grpId="0" nodeType="withEffect">
-                                  <p:stCondLst>
-                                    <p:cond delay="0"/>
-                                  </p:stCondLst>
-                                  <p:childTnLst>
-                                    <p:set>
-                                      <p:cBhvr>
-                                        <p:cTn id="18" dur="1" fill="hold">
-                                          <p:stCondLst>
-                                            <p:cond delay="0"/>
-                                          </p:stCondLst>
-                                        </p:cTn>
-                                        <p:tgtEl>
-                                          <p:spTgt spid="61"/>
-                                        </p:tgtEl>
-                                        <p:attrNameLst>
-                                          <p:attrName>style.visibility</p:attrName>
-                                        </p:attrNameLst>
-                                      </p:cBhvr>
-                                      <p:to>
-                                        <p:strVal val="visible"/>
-                                      </p:to>
-                                    </p:set>
-                                  </p:childTnLst>
-                                </p:cTn>
-                              </p:par>
-                              <p:par>
-                                <p:cTn id="19" presetID="1" presetClass="entr" presetSubtype="0" fill="hold" grpId="0" nodeType="withEffect">
-                                  <p:stCondLst>
-                                    <p:cond delay="0"/>
-                                  </p:stCondLst>
-                                  <p:childTnLst>
-                                    <p:set>
-                                      <p:cBhvr>
-                                        <p:cTn id="20" dur="1" fill="hold">
-                                          <p:stCondLst>
-                                            <p:cond delay="0"/>
-                                          </p:stCondLst>
-                                        </p:cTn>
-                                        <p:tgtEl>
-                                          <p:spTgt spid="62"/>
-                                        </p:tgtEl>
-                                        <p:attrNameLst>
-                                          <p:attrName>style.visibility</p:attrName>
-                                        </p:attrNameLst>
-                                      </p:cBhvr>
-                                      <p:to>
-                                        <p:strVal val="visible"/>
-                                      </p:to>
-                                    </p:set>
-                                  </p:childTnLst>
-                                </p:cTn>
-                              </p:par>
-                            </p:childTnLst>
-                          </p:cTn>
-                        </p:par>
-                      </p:childTnLst>
-                    </p:cTn>
-                  </p:par>
-                  <p:par>
-                    <p:cTn id="21" fill="hold">
-                      <p:stCondLst>
-                        <p:cond delay="indefinite"/>
-                      </p:stCondLst>
-                      <p:childTnLst>
-                        <p:par>
-                          <p:cTn id="22" fill="hold">
-                            <p:stCondLst>
-                              <p:cond delay="0"/>
-                            </p:stCondLst>
-                            <p:childTnLst>
-                              <p:par>
-                                <p:cTn id="23" presetID="1" presetClass="entr" presetSubtype="0" fill="hold" grpId="0" nodeType="clickEffect">
-                                  <p:stCondLst>
-                                    <p:cond delay="0"/>
-                                  </p:stCondLst>
-                                  <p:childTnLst>
-                                    <p:set>
-                                      <p:cBhvr>
-                                        <p:cTn id="24" dur="1" fill="hold">
-                                          <p:stCondLst>
-                                            <p:cond delay="0"/>
-                                          </p:stCondLst>
-                                        </p:cTn>
-                                        <p:tgtEl>
-                                          <p:spTgt spid="63"/>
-                                        </p:tgtEl>
-                                        <p:attrNameLst>
-                                          <p:attrName>style.visibility</p:attrName>
-                                        </p:attrNameLst>
-                                      </p:cBhvr>
-                                      <p:to>
-                                        <p:strVal val="visible"/>
-                                      </p:to>
-                                    </p:set>
-                                  </p:childTnLst>
-                                </p:cTn>
-                              </p:par>
-                            </p:childTnLst>
-                          </p:cTn>
-                        </p:par>
-                      </p:childTnLst>
-                    </p:cTn>
-                  </p:par>
-                </p:childTnLst>
-              </p:cTn>
-              <p:prevCondLst>
-                <p:cond evt="onPrev" delay="0">
-                  <p:tgtEl>
-                    <p:sldTgt/>
-                  </p:tgtEl>
-                </p:cond>
-              </p:prevCondLst>
-              <p:nextCondLst>
-                <p:cond evt="onNext" delay="0">
-                  <p:tgtEl>
-                    <p:sldTgt/>
-                  </p:tgtEl>
-                </p:cond>
-              </p:nextCondLst>
-            </p:seq>
-          </p:childTnLst>
-        </p:cTn>
-      </p:par>
-    </p:tnLst>
-    <p:bldLst>
-      <p:bldP spid="33" grpId="0" animBg="1"/>
-      <p:bldP spid="48" grpId="0"/>
-      <p:bldP spid="50" grpId="0"/>
-      <p:bldP spid="56" grpId="0" animBg="1"/>
-      <p:bldP spid="59" grpId="0"/>
-      <p:bldP spid="60" grpId="0"/>
-      <p:bldP spid="61" grpId="0"/>
-      <p:bldP spid="62" grpId="0"/>
-      <p:bldP spid="63" grpId="0" animBg="1"/>
-    </p:bldLst>
-  </p:timing>
 </p:sld>
 </file>
 

</xml_diff>